<commit_message>
Rebuild State of Knowledge deck: fix image sizing, add stats table
Fixed histogram image overflow (was 15in on 7.5in slide).
Added cross-plot statistics table as dedicated slide with r², slope,
intercept for all site/comparison combinations. Addis rows highlighted.
All images properly sized with no text overlap.
12 slides, confident results only.

https://claude.ai/code/session_012Xp6uacdCJm1dCzATLNVcd
</commit_message>
<xml_diff>
--- a/research/ftir_hips_chem/output/state_of_knowledge_presentation.pptx
+++ b/research/ftir_hips_chem/output/state_of_knowledge_presentation.pptx
@@ -16,6 +16,7 @@
     <p:sldId id="264" r:id="rId15"/>
     <p:sldId id="265" r:id="rId16"/>
     <p:sldId id="266" r:id="rId17"/>
+    <p:sldId id="267" r:id="rId18"/>
   </p:sldIdLst>
   <p:sldSz cx="12191695" cy="6858000" type="screen4x3"/>
   <p:notesSz cx="6858000" cy="9144000"/>
@@ -3106,8 +3107,8 @@
         </p:nvSpPr>
         <p:spPr>
           <a:xfrm>
-            <a:off x="457200" y="2286000"/>
-            <a:ext cx="10972800" cy="1828800"/>
+            <a:off x="457200" y="1828800"/>
+            <a:ext cx="10972800" cy="2286000"/>
           </a:xfrm>
           <a:prstGeom prst="rect">
             <a:avLst/>
@@ -3121,7 +3122,7 @@
           <a:lstStyle/>
           <a:p>
             <a:pPr algn="ctr">
-              <a:defRPr sz="3600" b="1">
+              <a:defRPr sz="4000" b="1">
                 <a:solidFill>
                   <a:srgbClr val="2C3E50"/>
                 </a:solidFill>
@@ -3133,7 +3134,7 @@
           </a:p>
           <a:p>
             <a:pPr algn="ctr">
-              <a:defRPr sz="1800">
+              <a:defRPr sz="2000">
                 <a:solidFill>
                   <a:srgbClr val="7F8C8D"/>
                 </a:solidFill>
@@ -3142,9 +3143,17 @@
             <a:r>
               <a:t>Confident Results — Multi-Site BC Measurement Comparison</a:t>
             </a:r>
-            <a:br/>
-            <a:r>
-              <a:t>If we had to write the paper today, here is what we have.</a:t>
+          </a:p>
+          <a:p>
+            <a:pPr algn="ctr">
+              <a:defRPr sz="1600" i="1">
+                <a:solidFill>
+                  <a:srgbClr val="95A5A6"/>
+                </a:solidFill>
+              </a:defRPr>
+            </a:pPr>
+            <a:r>
+              <a:t>"If we had to write the paper today, here is what we have."</a:t>
             </a:r>
           </a:p>
         </p:txBody>
@@ -3175,8 +3184,8 @@
         </p:nvSpPr>
         <p:spPr>
           <a:xfrm>
-            <a:off x="274320" y="182880"/>
-            <a:ext cx="11430000" cy="640080"/>
+            <a:off x="274320" y="137160"/>
+            <a:ext cx="11430000" cy="502920"/>
           </a:xfrm>
           <a:prstGeom prst="rect">
             <a:avLst/>
@@ -3190,14 +3199,14 @@
           <a:lstStyle/>
           <a:p>
             <a:pPr>
-              <a:defRPr sz="2400" b="1">
+              <a:defRPr sz="2200" b="1">
                 <a:solidFill>
                   <a:srgbClr val="2C3E50"/>
                 </a:solidFill>
               </a:defRPr>
             </a:pPr>
             <a:r>
-              <a:t>What We Can Confidently Say in the Paper</a:t>
+              <a:t>Result 6: Systematic Hypothesis Testing (11 Approaches)</a:t>
             </a:r>
           </a:p>
         </p:txBody>
@@ -3210,8 +3219,8 @@
         </p:nvSpPr>
         <p:spPr>
           <a:xfrm>
-            <a:off x="457200" y="914400"/>
-            <a:ext cx="10972800" cy="5486400"/>
+            <a:off x="457200" y="777240"/>
+            <a:ext cx="10972800" cy="5669280"/>
           </a:xfrm>
           <a:prstGeom prst="rect">
             <a:avLst/>
@@ -3226,229 +3235,193 @@
           <a:p>
             <a:pPr>
               <a:spcAft>
-                <a:spcPts val="800"/>
-              </a:spcAft>
-              <a:defRPr sz="1600">
-                <a:solidFill>
-                  <a:srgbClr val="2C3E50"/>
-                </a:solidFill>
-              </a:defRPr>
-            </a:pPr>
-            <a:r>
-              <a:t>1. HIPS and FTIR EC agree well at low-concentration sites</a:t>
-            </a:r>
-          </a:p>
-          <a:p>
-            <a:pPr>
-              <a:spcAft>
-                <a:spcPts val="800"/>
-              </a:spcAft>
-              <a:defRPr sz="1600">
-                <a:solidFill>
-                  <a:srgbClr val="2C3E50"/>
-                </a:solidFill>
-              </a:defRPr>
-            </a:pPr>
-            <a:r>
-              <a:t>   (Beijing, JPL) with MAC = 10</a:t>
-            </a:r>
-          </a:p>
-          <a:p>
-            <a:pPr>
-              <a:spcAft>
-                <a:spcPts val="800"/>
-              </a:spcAft>
-              <a:defRPr sz="1600">
-                <a:solidFill>
-                  <a:srgbClr val="2C3E50"/>
-                </a:solidFill>
-              </a:defRPr>
-            </a:pPr>
-          </a:p>
-          <a:p>
-            <a:pPr>
-              <a:spcAft>
-                <a:spcPts val="800"/>
-              </a:spcAft>
-              <a:defRPr sz="1600">
-                <a:solidFill>
-                  <a:srgbClr val="2C3E50"/>
-                </a:solidFill>
-              </a:defRPr>
-            </a:pPr>
-            <a:r>
-              <a:t>2. Delhi (high concentration) also shows good agreement,</a:t>
-            </a:r>
-          </a:p>
-          <a:p>
-            <a:pPr>
-              <a:spcAft>
-                <a:spcPts val="800"/>
-              </a:spcAft>
-              <a:defRPr sz="1600">
-                <a:solidFill>
-                  <a:srgbClr val="2C3E50"/>
-                </a:solidFill>
-              </a:defRPr>
-            </a:pPr>
-            <a:r>
-              <a:t>   confirming the anomaly is site-specific, not concentration-dependent</a:t>
-            </a:r>
-          </a:p>
-          <a:p>
-            <a:pPr>
-              <a:spcAft>
-                <a:spcPts val="800"/>
-              </a:spcAft>
-              <a:defRPr sz="1600">
-                <a:solidFill>
-                  <a:srgbClr val="2C3E50"/>
-                </a:solidFill>
-              </a:defRPr>
-            </a:pPr>
-          </a:p>
-          <a:p>
-            <a:pPr>
-              <a:spcAft>
-                <a:spcPts val="800"/>
-              </a:spcAft>
-              <a:defRPr sz="1600">
-                <a:solidFill>
-                  <a:srgbClr val="2C3E50"/>
-                </a:solidFill>
-              </a:defRPr>
-            </a:pPr>
-            <a:r>
-              <a:t>3. Addis Ababa shows a persistent HIPS offset and compressed</a:t>
-            </a:r>
-          </a:p>
-          <a:p>
-            <a:pPr>
-              <a:spcAft>
-                <a:spcPts val="800"/>
-              </a:spcAft>
-              <a:defRPr sz="1600">
-                <a:solidFill>
-                  <a:srgbClr val="2C3E50"/>
-                </a:solidFill>
-              </a:defRPr>
-            </a:pPr>
-            <a:r>
-              <a:t>   dynamic range that is NOT explained by:</a:t>
-            </a:r>
-          </a:p>
-          <a:p>
-            <a:pPr>
-              <a:spcAft>
-                <a:spcPts val="800"/>
-              </a:spcAft>
-              <a:defRPr sz="1600">
-                <a:solidFill>
-                  <a:srgbClr val="2C3E50"/>
-                </a:solidFill>
-              </a:defRPr>
-            </a:pPr>
-            <a:r>
-              <a:t>   iron, dust, humidity, temperature, optical saturation,</a:t>
-            </a:r>
-          </a:p>
-          <a:p>
-            <a:pPr>
-              <a:spcAft>
-                <a:spcPts val="800"/>
-              </a:spcAft>
-              <a:defRPr sz="1600">
-                <a:solidFill>
-                  <a:srgbClr val="2C3E50"/>
-                </a:solidFill>
-              </a:defRPr>
-            </a:pPr>
-            <a:r>
-              <a:t>   source composition, or season</a:t>
-            </a:r>
-          </a:p>
-          <a:p>
-            <a:pPr>
-              <a:spcAft>
-                <a:spcPts val="800"/>
-              </a:spcAft>
-              <a:defRPr sz="1600">
-                <a:solidFill>
-                  <a:srgbClr val="2C3E50"/>
-                </a:solidFill>
-              </a:defRPr>
-            </a:pPr>
-          </a:p>
-          <a:p>
-            <a:pPr>
-              <a:spcAft>
-                <a:spcPts val="800"/>
-              </a:spcAft>
-              <a:defRPr sz="1600">
-                <a:solidFill>
-                  <a:srgbClr val="2C3E50"/>
-                </a:solidFill>
-              </a:defRPr>
-            </a:pPr>
-            <a:r>
-              <a:t>4. The Addis aethalometer has a confirmed instrument/data issue</a:t>
-            </a:r>
-          </a:p>
-          <a:p>
-            <a:pPr>
-              <a:spcAft>
-                <a:spcPts val="800"/>
-              </a:spcAft>
-              <a:defRPr sz="1600">
-                <a:solidFill>
-                  <a:srgbClr val="2C3E50"/>
-                </a:solidFill>
-              </a:defRPr>
-            </a:pPr>
-            <a:r>
-              <a:t>   (Green channel at 0.55x IR — unique across all sites)</a:t>
-            </a:r>
-          </a:p>
-          <a:p>
-            <a:pPr>
-              <a:spcAft>
-                <a:spcPts val="800"/>
-              </a:spcAft>
-              <a:defRPr sz="1600">
-                <a:solidFill>
-                  <a:srgbClr val="2C3E50"/>
-                </a:solidFill>
-              </a:defRPr>
-            </a:pPr>
-          </a:p>
-          <a:p>
-            <a:pPr>
-              <a:spcAft>
-                <a:spcPts val="800"/>
-              </a:spcAft>
-              <a:defRPr sz="1600">
-                <a:solidFill>
-                  <a:srgbClr val="2C3E50"/>
-                </a:solidFill>
-              </a:defRPr>
-            </a:pPr>
-            <a:r>
-              <a:t>5. Seasonal analysis is essential — aggregated data hides</a:t>
-            </a:r>
-          </a:p>
-          <a:p>
-            <a:pPr>
-              <a:spcAft>
-                <a:spcPts val="800"/>
-              </a:spcAft>
-              <a:defRPr sz="1600">
-                <a:solidFill>
-                  <a:srgbClr val="2C3E50"/>
-                </a:solidFill>
-              </a:defRPr>
-            </a:pPr>
-            <a:r>
-              <a:t>   meaningful patterns at all sites</a:t>
+                <a:spcPts val="400"/>
+              </a:spcAft>
+              <a:defRPr sz="1500">
+                <a:solidFill>
+                  <a:srgbClr val="34495E"/>
+                </a:solidFill>
+              </a:defRPr>
+            </a:pPr>
+            <a:r>
+              <a:t>Tested and did NOT explain the Addis anomaly:</a:t>
+            </a:r>
+          </a:p>
+          <a:p>
+            <a:pPr>
+              <a:spcAft>
+                <a:spcPts val="400"/>
+              </a:spcAft>
+              <a:defRPr sz="1500">
+                <a:solidFill>
+                  <a:srgbClr val="34495E"/>
+                </a:solidFill>
+              </a:defRPr>
+            </a:pPr>
+          </a:p>
+          <a:p>
+            <a:pPr>
+              <a:spcAft>
+                <a:spcPts val="400"/>
+              </a:spcAft>
+              <a:defRPr sz="1500">
+                <a:solidFill>
+                  <a:srgbClr val="34495E"/>
+                </a:solidFill>
+              </a:defRPr>
+            </a:pPr>
+            <a:r>
+              <a:t>  1. Relative humidity thresholds    -&gt; sample sizes too small to conclude</a:t>
+            </a:r>
+          </a:p>
+          <a:p>
+            <a:pPr>
+              <a:spcAft>
+                <a:spcPts val="400"/>
+              </a:spcAft>
+              <a:defRPr sz="1500">
+                <a:solidFill>
+                  <a:srgbClr val="34495E"/>
+                </a:solidFill>
+              </a:defRPr>
+            </a:pPr>
+            <a:r>
+              <a:t>  2. Temperature (T_min, T_max)      -&gt; counterintuitive (burning peaks when warmer)</a:t>
+            </a:r>
+          </a:p>
+          <a:p>
+            <a:pPr>
+              <a:spcAft>
+                <a:spcPts val="400"/>
+              </a:spcAft>
+              <a:defRPr sz="1500">
+                <a:solidFill>
+                  <a:srgbClr val="34495E"/>
+                </a:solidFill>
+              </a:defRPr>
+            </a:pPr>
+            <a:r>
+              <a:t>  3. Optical saturation              -&gt; no curvature (linear throughout)</a:t>
+            </a:r>
+          </a:p>
+          <a:p>
+            <a:pPr>
+              <a:spcAft>
+                <a:spcPts val="400"/>
+              </a:spcAft>
+              <a:defRPr sz="1500">
+                <a:solidFill>
+                  <a:srgbClr val="34495E"/>
+                </a:solidFill>
+              </a:defRPr>
+            </a:pPr>
+            <a:r>
+              <a:t>  4. Influential point removal       -&gt; dataset too tight, no leverage points</a:t>
+            </a:r>
+          </a:p>
+          <a:p>
+            <a:pPr>
+              <a:spcAft>
+                <a:spcPts val="400"/>
+              </a:spcAft>
+              <a:defRPr sz="1500">
+                <a:solidFill>
+                  <a:srgbClr val="34495E"/>
+                </a:solidFill>
+              </a:defRPr>
+            </a:pPr>
+            <a:r>
+              <a:t>  5. OC/EC ratio analysis            -&gt; no additional insight</a:t>
+            </a:r>
+          </a:p>
+          <a:p>
+            <a:pPr>
+              <a:spcAft>
+                <a:spcPts val="400"/>
+              </a:spcAft>
+              <a:defRPr sz="1500">
+                <a:solidFill>
+                  <a:srgbClr val="34495E"/>
+                </a:solidFill>
+              </a:defRPr>
+            </a:pPr>
+            <a:r>
+              <a:t>  6. Dust (AERONET coarse AOD)       -&gt; r = -0.33 (RULES OUT dust)</a:t>
+            </a:r>
+          </a:p>
+          <a:p>
+            <a:pPr>
+              <a:spcAft>
+                <a:spcPts val="400"/>
+              </a:spcAft>
+              <a:defRPr sz="1500">
+                <a:solidFill>
+                  <a:srgbClr val="34495E"/>
+                </a:solidFill>
+              </a:defRPr>
+            </a:pPr>
+            <a:r>
+              <a:t>  7. Iron/EC ratio thresholds        -&gt; iron not causing slope discrepancies</a:t>
+            </a:r>
+          </a:p>
+          <a:p>
+            <a:pPr>
+              <a:spcAft>
+                <a:spcPts val="400"/>
+              </a:spcAft>
+              <a:defRPr sz="1500">
+                <a:solidFill>
+                  <a:srgbClr val="34495E"/>
+                </a:solidFill>
+              </a:defRPr>
+            </a:pPr>
+            <a:r>
+              <a:t>  8. Source apportionment (PMF)      -&gt; all sources show same slopes</a:t>
+            </a:r>
+          </a:p>
+          <a:p>
+            <a:pPr>
+              <a:spcAft>
+                <a:spcPts val="400"/>
+              </a:spcAft>
+              <a:defRPr sz="1500">
+                <a:solidFill>
+                  <a:srgbClr val="34495E"/>
+                </a:solidFill>
+              </a:defRPr>
+            </a:pPr>
+            <a:r>
+              <a:t>  9. Combined source grouping        -&gt; biomass vs fossil fuel overlap</a:t>
+            </a:r>
+          </a:p>
+          <a:p>
+            <a:pPr>
+              <a:spcAft>
+                <a:spcPts val="400"/>
+              </a:spcAft>
+              <a:defRPr sz="1500">
+                <a:solidFill>
+                  <a:srgbClr val="34495E"/>
+                </a:solidFill>
+              </a:defRPr>
+            </a:pPr>
+            <a:r>
+              <a:t> 10. All-season aggregation          -&gt; masks patterns, doesn't explain</a:t>
+            </a:r>
+          </a:p>
+          <a:p>
+            <a:pPr>
+              <a:spcAft>
+                <a:spcPts val="400"/>
+              </a:spcAft>
+              <a:defRPr sz="1500">
+                <a:solidFill>
+                  <a:srgbClr val="34495E"/>
+                </a:solidFill>
+              </a:defRPr>
+            </a:pPr>
+            <a:r>
+              <a:t> 11. Wavelength stacking (IR=Blue=Red) -&gt; unique to Addis = instrument issue</a:t>
             </a:r>
           </a:p>
         </p:txBody>
@@ -3479,8 +3452,8 @@
         </p:nvSpPr>
         <p:spPr>
           <a:xfrm>
-            <a:off x="274320" y="182880"/>
-            <a:ext cx="11430000" cy="640080"/>
+            <a:off x="274320" y="137160"/>
+            <a:ext cx="11430000" cy="502920"/>
           </a:xfrm>
           <a:prstGeom prst="rect">
             <a:avLst/>
@@ -3494,14 +3467,14 @@
           <a:lstStyle/>
           <a:p>
             <a:pPr>
-              <a:defRPr sz="2400" b="1">
+              <a:defRPr sz="2200" b="1">
                 <a:solidFill>
                   <a:srgbClr val="2C3E50"/>
                 </a:solidFill>
               </a:defRPr>
             </a:pPr>
             <a:r>
-              <a:t>What We Still Need Before Writing</a:t>
+              <a:t>What We Can Confidently Write</a:t>
             </a:r>
           </a:p>
         </p:txBody>
@@ -3514,8 +3487,8 @@
         </p:nvSpPr>
         <p:spPr>
           <a:xfrm>
-            <a:off x="457200" y="914400"/>
-            <a:ext cx="10972800" cy="5486400"/>
+            <a:off x="457200" y="777240"/>
+            <a:ext cx="10972800" cy="5669280"/>
           </a:xfrm>
           <a:prstGeom prst="rect">
             <a:avLst/>
@@ -3530,56 +3503,474 @@
           <a:p>
             <a:pPr>
               <a:spcAft>
-                <a:spcPts val="800"/>
-              </a:spcAft>
-              <a:defRPr sz="1600">
+                <a:spcPts val="400"/>
+              </a:spcAft>
+              <a:defRPr sz="1600">
+                <a:solidFill>
+                  <a:srgbClr val="34495E"/>
+                </a:solidFill>
+              </a:defRPr>
+            </a:pPr>
+            <a:r>
+              <a:t>1. HIPS and FTIR EC agree well at low-concentration sites</a:t>
+            </a:r>
+          </a:p>
+          <a:p>
+            <a:pPr>
+              <a:spcAft>
+                <a:spcPts val="400"/>
+              </a:spcAft>
+              <a:defRPr sz="1600">
+                <a:solidFill>
+                  <a:srgbClr val="34495E"/>
+                </a:solidFill>
+              </a:defRPr>
+            </a:pPr>
+            <a:r>
+              <a:t>   (Beijing, JPL) with MAC = 10. Iron has no measurable effect.</a:t>
+            </a:r>
+          </a:p>
+          <a:p>
+            <a:pPr>
+              <a:spcAft>
+                <a:spcPts val="400"/>
+              </a:spcAft>
+              <a:defRPr sz="1600">
+                <a:solidFill>
+                  <a:srgbClr val="34495E"/>
+                </a:solidFill>
+              </a:defRPr>
+            </a:pPr>
+          </a:p>
+          <a:p>
+            <a:pPr>
+              <a:spcAft>
+                <a:spcPts val="400"/>
+              </a:spcAft>
+              <a:defRPr sz="1600">
+                <a:solidFill>
+                  <a:srgbClr val="34495E"/>
+                </a:solidFill>
+              </a:defRPr>
+            </a:pPr>
+            <a:r>
+              <a:t>2. Delhi (high concentration) also shows good agreement,</a:t>
+            </a:r>
+          </a:p>
+          <a:p>
+            <a:pPr>
+              <a:spcAft>
+                <a:spcPts val="400"/>
+              </a:spcAft>
+              <a:defRPr sz="1600">
+                <a:solidFill>
+                  <a:srgbClr val="34495E"/>
+                </a:solidFill>
+              </a:defRPr>
+            </a:pPr>
+            <a:r>
+              <a:t>   confirming the anomaly is site-specific, not concentration-dependent.</a:t>
+            </a:r>
+          </a:p>
+          <a:p>
+            <a:pPr>
+              <a:spcAft>
+                <a:spcPts val="400"/>
+              </a:spcAft>
+              <a:defRPr sz="1600">
+                <a:solidFill>
+                  <a:srgbClr val="34495E"/>
+                </a:solidFill>
+              </a:defRPr>
+            </a:pPr>
+          </a:p>
+          <a:p>
+            <a:pPr>
+              <a:spcAft>
+                <a:spcPts val="400"/>
+              </a:spcAft>
+              <a:defRPr sz="1600">
+                <a:solidFill>
+                  <a:srgbClr val="34495E"/>
+                </a:solidFill>
+              </a:defRPr>
+            </a:pPr>
+            <a:r>
+              <a:t>3. Addis Ababa shows a persistent HIPS offset (~2 ug/m3) and</a:t>
+            </a:r>
+          </a:p>
+          <a:p>
+            <a:pPr>
+              <a:spcAft>
+                <a:spcPts val="400"/>
+              </a:spcAft>
+              <a:defRPr sz="1600">
+                <a:solidFill>
+                  <a:srgbClr val="34495E"/>
+                </a:solidFill>
+              </a:defRPr>
+            </a:pPr>
+            <a:r>
+              <a:t>   compressed dynamic range that is NOT explained by: iron, dust,</a:t>
+            </a:r>
+          </a:p>
+          <a:p>
+            <a:pPr>
+              <a:spcAft>
+                <a:spcPts val="400"/>
+              </a:spcAft>
+              <a:defRPr sz="1600">
+                <a:solidFill>
+                  <a:srgbClr val="34495E"/>
+                </a:solidFill>
+              </a:defRPr>
+            </a:pPr>
+            <a:r>
+              <a:t>   humidity, temperature, optical saturation, or source composition.</a:t>
+            </a:r>
+          </a:p>
+          <a:p>
+            <a:pPr>
+              <a:spcAft>
+                <a:spcPts val="400"/>
+              </a:spcAft>
+              <a:defRPr sz="1600">
+                <a:solidFill>
+                  <a:srgbClr val="34495E"/>
+                </a:solidFill>
+              </a:defRPr>
+            </a:pPr>
+          </a:p>
+          <a:p>
+            <a:pPr>
+              <a:spcAft>
+                <a:spcPts val="400"/>
+              </a:spcAft>
+              <a:defRPr sz="1600">
+                <a:solidFill>
+                  <a:srgbClr val="34495E"/>
+                </a:solidFill>
+              </a:defRPr>
+            </a:pPr>
+            <a:r>
+              <a:t>4. The Addis aethalometer has a confirmed data quality issue</a:t>
+            </a:r>
+          </a:p>
+          <a:p>
+            <a:pPr>
+              <a:spcAft>
+                <a:spcPts val="400"/>
+              </a:spcAft>
+              <a:defRPr sz="1600">
+                <a:solidFill>
+                  <a:srgbClr val="34495E"/>
+                </a:solidFill>
+              </a:defRPr>
+            </a:pPr>
+            <a:r>
+              <a:t>   (Green channel at 0.55x IR — unique across all four sites),</a:t>
+            </a:r>
+          </a:p>
+          <a:p>
+            <a:pPr>
+              <a:spcAft>
+                <a:spcPts val="400"/>
+              </a:spcAft>
+              <a:defRPr sz="1600">
+                <a:solidFill>
+                  <a:srgbClr val="34495E"/>
+                </a:solidFill>
+              </a:defRPr>
+            </a:pPr>
+            <a:r>
+              <a:t>   but this does not directly explain the HIPS-FTIR discrepancy.</a:t>
+            </a:r>
+          </a:p>
+          <a:p>
+            <a:pPr>
+              <a:spcAft>
+                <a:spcPts val="400"/>
+              </a:spcAft>
+              <a:defRPr sz="1600">
+                <a:solidFill>
+                  <a:srgbClr val="34495E"/>
+                </a:solidFill>
+              </a:defRPr>
+            </a:pPr>
+          </a:p>
+          <a:p>
+            <a:pPr>
+              <a:spcAft>
+                <a:spcPts val="400"/>
+              </a:spcAft>
+              <a:defRPr sz="1600">
+                <a:solidFill>
+                  <a:srgbClr val="34495E"/>
+                </a:solidFill>
+              </a:defRPr>
+            </a:pPr>
+            <a:r>
+              <a:t>5. Seasonal analysis is essential — aggregated data hides</a:t>
+            </a:r>
+          </a:p>
+          <a:p>
+            <a:pPr>
+              <a:spcAft>
+                <a:spcPts val="400"/>
+              </a:spcAft>
+              <a:defRPr sz="1600">
+                <a:solidFill>
+                  <a:srgbClr val="34495E"/>
+                </a:solidFill>
+              </a:defRPr>
+            </a:pPr>
+            <a:r>
+              <a:t>   meaningful patterns at all sites.</a:t>
+            </a:r>
+          </a:p>
+        </p:txBody>
+      </p:sp>
+    </p:spTree>
+  </p:cSld>
+  <p:clrMapOvr>
+    <a:masterClrMapping/>
+  </p:clrMapOvr>
+</p:sld>
+</file>
+
+<file path=ppt/slides/slide12.xml><?xml version="1.0" encoding="utf-8"?>
+<p:sld xmlns:a="http://schemas.openxmlformats.org/drawingml/2006/main" xmlns:p="http://schemas.openxmlformats.org/presentationml/2006/main" xmlns:r="http://schemas.openxmlformats.org/officeDocument/2006/relationships">
+  <p:cSld>
+    <p:spTree>
+      <p:nvGrpSpPr>
+        <p:cNvPr id="1" name=""/>
+        <p:cNvGrpSpPr/>
+        <p:nvPr/>
+      </p:nvGrpSpPr>
+      <p:grpSpPr/>
+      <p:sp>
+        <p:nvSpPr>
+          <p:cNvPr id="2" name="TextBox 1"/>
+          <p:cNvSpPr txBox="1"/>
+          <p:nvPr/>
+        </p:nvSpPr>
+        <p:spPr>
+          <a:xfrm>
+            <a:off x="274320" y="137160"/>
+            <a:ext cx="11430000" cy="502920"/>
+          </a:xfrm>
+          <a:prstGeom prst="rect">
+            <a:avLst/>
+          </a:prstGeom>
+          <a:noFill/>
+        </p:spPr>
+        <p:txBody>
+          <a:bodyPr wrap="none">
+            <a:spAutoFit/>
+          </a:bodyPr>
+          <a:lstStyle/>
+          <a:p>
+            <a:pPr>
+              <a:defRPr sz="2200" b="1">
                 <a:solidFill>
                   <a:srgbClr val="2C3E50"/>
                 </a:solidFill>
               </a:defRPr>
             </a:pPr>
             <a:r>
-              <a:t>HIGH PRIORITY:</a:t>
-            </a:r>
-          </a:p>
-          <a:p>
-            <a:pPr>
-              <a:spcAft>
-                <a:spcPts val="800"/>
-              </a:spcAft>
-              <a:defRPr sz="1600">
-                <a:solidFill>
-                  <a:srgbClr val="2C3E50"/>
-                </a:solidFill>
-              </a:defRPr>
-            </a:pPr>
-            <a:r>
-              <a:t>  - Paper skeleton: define the story, figure order, conclusions</a:t>
-            </a:r>
-          </a:p>
-          <a:p>
-            <a:pPr>
-              <a:spcAft>
-                <a:spcPts val="800"/>
-              </a:spcAft>
-              <a:defRPr sz="1600">
-                <a:solidFill>
-                  <a:srgbClr val="2C3E50"/>
-                </a:solidFill>
-              </a:defRPr>
-            </a:pPr>
-            <a:r>
-              <a:t>  - Meet with Cena to show progress and get guidance on Addis anomaly</a:t>
-            </a:r>
-          </a:p>
-          <a:p>
-            <a:pPr>
-              <a:spcAft>
-                <a:spcPts val="800"/>
-              </a:spcAft>
-              <a:defRPr sz="1600">
-                <a:solidFill>
-                  <a:srgbClr val="2C3E50"/>
+              <a:t>What We Still Need</a:t>
+            </a:r>
+          </a:p>
+        </p:txBody>
+      </p:sp>
+      <p:sp>
+        <p:nvSpPr>
+          <p:cNvPr id="3" name="TextBox 2"/>
+          <p:cNvSpPr txBox="1"/>
+          <p:nvPr/>
+        </p:nvSpPr>
+        <p:spPr>
+          <a:xfrm>
+            <a:off x="457200" y="777240"/>
+            <a:ext cx="10972800" cy="5669280"/>
+          </a:xfrm>
+          <a:prstGeom prst="rect">
+            <a:avLst/>
+          </a:prstGeom>
+          <a:noFill/>
+        </p:spPr>
+        <p:txBody>
+          <a:bodyPr wrap="square">
+            <a:spAutoFit/>
+          </a:bodyPr>
+          <a:lstStyle/>
+          <a:p>
+            <a:pPr>
+              <a:spcAft>
+                <a:spcPts val="400"/>
+              </a:spcAft>
+              <a:defRPr sz="1600">
+                <a:solidFill>
+                  <a:srgbClr val="34495E"/>
+                </a:solidFill>
+              </a:defRPr>
+            </a:pPr>
+            <a:r>
+              <a:t>TO WRITE THE PAPER:</a:t>
+            </a:r>
+          </a:p>
+          <a:p>
+            <a:pPr>
+              <a:spcAft>
+                <a:spcPts val="400"/>
+              </a:spcAft>
+              <a:defRPr sz="1600">
+                <a:solidFill>
+                  <a:srgbClr val="34495E"/>
+                </a:solidFill>
+              </a:defRPr>
+            </a:pPr>
+            <a:r>
+              <a:t>  - Paper skeleton: define the story, figure order, conclusions first</a:t>
+            </a:r>
+          </a:p>
+          <a:p>
+            <a:pPr>
+              <a:spcAft>
+                <a:spcPts val="400"/>
+              </a:spcAft>
+              <a:defRPr sz="1600">
+                <a:solidFill>
+                  <a:srgbClr val="34495E"/>
+                </a:solidFill>
+              </a:defRPr>
+            </a:pPr>
+            <a:r>
+              <a:t>  - Final figure set (cross-plots + distributions + stats table)</a:t>
+            </a:r>
+          </a:p>
+          <a:p>
+            <a:pPr>
+              <a:spcAft>
+                <a:spcPts val="400"/>
+              </a:spcAft>
+              <a:defRPr sz="1600">
+                <a:solidFill>
+                  <a:srgbClr val="34495E"/>
+                </a:solidFill>
+              </a:defRPr>
+            </a:pPr>
+          </a:p>
+          <a:p>
+            <a:pPr>
+              <a:spcAft>
+                <a:spcPts val="400"/>
+              </a:spcAft>
+              <a:defRPr sz="1600">
+                <a:solidFill>
+                  <a:srgbClr val="34495E"/>
+                </a:solidFill>
+              </a:defRPr>
+            </a:pPr>
+            <a:r>
+              <a:t>TO RESOLVE THE ANOMALY:</a:t>
+            </a:r>
+          </a:p>
+          <a:p>
+            <a:pPr>
+              <a:spcAft>
+                <a:spcPts val="400"/>
+              </a:spcAft>
+              <a:defRPr sz="1600">
+                <a:solidFill>
+                  <a:srgbClr val="34495E"/>
+                </a:solidFill>
+              </a:defRPr>
+            </a:pPr>
+            <a:r>
+              <a:t>  - Meet with Cena to discuss:</a:t>
+            </a:r>
+          </a:p>
+          <a:p>
+            <a:pPr>
+              <a:spcAft>
+                <a:spcPts val="400"/>
+              </a:spcAft>
+              <a:defRPr sz="1600">
+                <a:solidFill>
+                  <a:srgbClr val="34495E"/>
+                </a:solidFill>
+              </a:defRPr>
+            </a:pPr>
+            <a:r>
+              <a:t>      Green channel issue on MA350-0238</a:t>
+            </a:r>
+          </a:p>
+          <a:p>
+            <a:pPr>
+              <a:spcAft>
+                <a:spcPts val="400"/>
+              </a:spcAft>
+              <a:defRPr sz="1600">
+                <a:solidFill>
+                  <a:srgbClr val="34495E"/>
+                </a:solidFill>
+              </a:defRPr>
+            </a:pPr>
+            <a:r>
+              <a:t>      HIPS anomaly root cause</a:t>
+            </a:r>
+          </a:p>
+          <a:p>
+            <a:pPr>
+              <a:spcAft>
+                <a:spcPts val="400"/>
+              </a:spcAft>
+              <a:defRPr sz="1600">
+                <a:solidFill>
+                  <a:srgbClr val="34495E"/>
+                </a:solidFill>
+              </a:defRPr>
+            </a:pPr>
+            <a:r>
+              <a:t>      Filter loading effects at high BC concentrations</a:t>
+            </a:r>
+          </a:p>
+          <a:p>
+            <a:pPr>
+              <a:spcAft>
+                <a:spcPts val="400"/>
+              </a:spcAft>
+              <a:defRPr sz="1600">
+                <a:solidFill>
+                  <a:srgbClr val="34495E"/>
+                </a:solidFill>
+              </a:defRPr>
+            </a:pPr>
+          </a:p>
+          <a:p>
+            <a:pPr>
+              <a:spcAft>
+                <a:spcPts val="400"/>
+              </a:spcAft>
+              <a:defRPr sz="1600">
+                <a:solidFill>
+                  <a:srgbClr val="34495E"/>
+                </a:solidFill>
+              </a:defRPr>
+            </a:pPr>
+            <a:r>
+              <a:t>TO COMPLETE:</a:t>
+            </a:r>
+          </a:p>
+          <a:p>
+            <a:pPr>
+              <a:spcAft>
+                <a:spcPts val="400"/>
+              </a:spcAft>
+              <a:defRPr sz="1600">
+                <a:solidFill>
+                  <a:srgbClr val="34495E"/>
                 </a:solidFill>
               </a:defRPr>
             </a:pPr>
@@ -3590,95 +3981,53 @@
           <a:p>
             <a:pPr>
               <a:spcAft>
-                <a:spcPts val="800"/>
-              </a:spcAft>
-              <a:defRPr sz="1600">
-                <a:solidFill>
-                  <a:srgbClr val="2C3E50"/>
-                </a:solidFill>
-              </a:defRPr>
-            </a:pPr>
-          </a:p>
-          <a:p>
-            <a:pPr>
-              <a:spcAft>
-                <a:spcPts val="800"/>
-              </a:spcAft>
-              <a:defRPr sz="1600">
-                <a:solidFill>
-                  <a:srgbClr val="2C3E50"/>
-                </a:solidFill>
-              </a:defRPr>
-            </a:pPr>
-            <a:r>
-              <a:t>OPEN QUESTIONS FOR CENA:</a:t>
-            </a:r>
-          </a:p>
-          <a:p>
-            <a:pPr>
-              <a:spcAft>
-                <a:spcPts val="800"/>
-              </a:spcAft>
-              <a:defRPr sz="1600">
-                <a:solidFill>
-                  <a:srgbClr val="2C3E50"/>
-                </a:solidFill>
-              </a:defRPr>
-            </a:pPr>
-            <a:r>
-              <a:t>  - Green channel issue on MA350-0238: known? correction available?</a:t>
-            </a:r>
-          </a:p>
-          <a:p>
-            <a:pPr>
-              <a:spcAft>
-                <a:spcPts val="800"/>
-              </a:spcAft>
-              <a:defRPr sz="1600">
-                <a:solidFill>
-                  <a:srgbClr val="2C3E50"/>
-                </a:solidFill>
-              </a:defRPr>
-            </a:pPr>
-            <a:r>
-              <a:t>  - HIPS anomaly: what else could cause persistent intercept + compression?</a:t>
-            </a:r>
-          </a:p>
-          <a:p>
-            <a:pPr>
-              <a:spcAft>
-                <a:spcPts val="800"/>
-              </a:spcAft>
-              <a:defRPr sz="1600">
-                <a:solidFill>
-                  <a:srgbClr val="2C3E50"/>
-                </a:solidFill>
-              </a:defRPr>
-            </a:pPr>
-            <a:r>
-              <a:t>  - Filter loading effects at high BC?</a:t>
-            </a:r>
-          </a:p>
-          <a:p>
-            <a:pPr>
-              <a:spcAft>
-                <a:spcPts val="800"/>
-              </a:spcAft>
-              <a:defRPr sz="1600">
-                <a:solidFill>
-                  <a:srgbClr val="2C3E50"/>
-                </a:solidFill>
-              </a:defRPr>
-            </a:pPr>
-          </a:p>
-          <a:p>
-            <a:pPr>
-              <a:spcAft>
-                <a:spcPts val="800"/>
-              </a:spcAft>
-              <a:defRPr sz="1600">
-                <a:solidFill>
-                  <a:srgbClr val="2C3E50"/>
+                <a:spcPts val="400"/>
+              </a:spcAft>
+              <a:defRPr sz="1600">
+                <a:solidFill>
+                  <a:srgbClr val="34495E"/>
+                </a:solidFill>
+              </a:defRPr>
+            </a:pPr>
+            <a:r>
+              <a:t>  - Literature: Warren White HIPS/IMPROVE papers</a:t>
+            </a:r>
+          </a:p>
+          <a:p>
+            <a:pPr>
+              <a:spcAft>
+                <a:spcPts val="400"/>
+              </a:spcAft>
+              <a:defRPr sz="1600">
+                <a:solidFill>
+                  <a:srgbClr val="34495E"/>
+                </a:solidFill>
+              </a:defRPr>
+            </a:pPr>
+            <a:r>
+              <a:t>  - Literature: filter-based absorption measurement corrections</a:t>
+            </a:r>
+          </a:p>
+          <a:p>
+            <a:pPr>
+              <a:spcAft>
+                <a:spcPts val="400"/>
+              </a:spcAft>
+              <a:defRPr sz="1600">
+                <a:solidFill>
+                  <a:srgbClr val="34495E"/>
+                </a:solidFill>
+              </a:defRPr>
+            </a:pPr>
+          </a:p>
+          <a:p>
+            <a:pPr>
+              <a:spcAft>
+                <a:spcPts val="400"/>
+              </a:spcAft>
+              <a:defRPr sz="1600">
+                <a:solidFill>
+                  <a:srgbClr val="34495E"/>
                 </a:solidFill>
               </a:defRPr>
             </a:pPr>
@@ -3689,11 +4038,11 @@
           <a:p>
             <a:pPr>
               <a:spcAft>
-                <a:spcPts val="800"/>
-              </a:spcAft>
-              <a:defRPr sz="1600">
-                <a:solidFill>
-                  <a:srgbClr val="2C3E50"/>
+                <a:spcPts val="400"/>
+              </a:spcAft>
+              <a:defRPr sz="1600">
+                <a:solidFill>
+                  <a:srgbClr val="34495E"/>
                 </a:solidFill>
               </a:defRPr>
             </a:pPr>
@@ -3704,31 +4053,16 @@
           <a:p>
             <a:pPr>
               <a:spcAft>
-                <a:spcPts val="800"/>
-              </a:spcAft>
-              <a:defRPr sz="1600">
-                <a:solidFill>
-                  <a:srgbClr val="2C3E50"/>
-                </a:solidFill>
-              </a:defRPr>
-            </a:pPr>
-            <a:r>
-              <a:t>   here is what we tried to explain it +</a:t>
-            </a:r>
-          </a:p>
-          <a:p>
-            <a:pPr>
-              <a:spcAft>
-                <a:spcPts val="800"/>
-              </a:spcAft>
-              <a:defRPr sz="1600">
-                <a:solidFill>
-                  <a:srgbClr val="2C3E50"/>
-                </a:solidFill>
-              </a:defRPr>
-            </a:pPr>
-            <a:r>
-              <a:t>   the anomaly remains an open question for further investigation"</a:t>
+                <a:spcPts val="400"/>
+              </a:spcAft>
+              <a:defRPr sz="1600">
+                <a:solidFill>
+                  <a:srgbClr val="34495E"/>
+                </a:solidFill>
+              </a:defRPr>
+            </a:pPr>
+            <a:r>
+              <a:t>   here is what we tried + anomaly remains open"</a:t>
             </a:r>
           </a:p>
         </p:txBody>
@@ -3759,8 +4093,8 @@
         </p:nvSpPr>
         <p:spPr>
           <a:xfrm>
-            <a:off x="274320" y="182880"/>
-            <a:ext cx="11430000" cy="640080"/>
+            <a:off x="274320" y="137160"/>
+            <a:ext cx="11430000" cy="502920"/>
           </a:xfrm>
           <a:prstGeom prst="rect">
             <a:avLst/>
@@ -3774,14 +4108,14 @@
           <a:lstStyle/>
           <a:p>
             <a:pPr>
-              <a:defRPr sz="2400" b="1">
+              <a:defRPr sz="2200" b="1">
                 <a:solidFill>
                   <a:srgbClr val="2C3E50"/>
                 </a:solidFill>
               </a:defRPr>
             </a:pPr>
             <a:r>
-              <a:t>The Story</a:t>
+              <a:t>The Story: Three Sites Work Well; Addis Is Anomalous</a:t>
             </a:r>
           </a:p>
         </p:txBody>
@@ -3794,8 +4128,8 @@
         </p:nvSpPr>
         <p:spPr>
           <a:xfrm>
-            <a:off x="457200" y="914400"/>
-            <a:ext cx="10972800" cy="5486400"/>
+            <a:off x="457200" y="777240"/>
+            <a:ext cx="10972800" cy="5669280"/>
           </a:xfrm>
           <a:prstGeom prst="rect">
             <a:avLst/>
@@ -3810,11 +4144,11 @@
           <a:p>
             <a:pPr>
               <a:spcAft>
-                <a:spcPts val="800"/>
-              </a:spcAft>
-              <a:defRPr sz="1600">
-                <a:solidFill>
-                  <a:srgbClr val="2C3E50"/>
+                <a:spcPts val="400"/>
+              </a:spcAft>
+              <a:defRPr sz="1600">
+                <a:solidFill>
+                  <a:srgbClr val="34495E"/>
                 </a:solidFill>
               </a:defRPr>
             </a:pPr>
@@ -3825,23 +4159,23 @@
           <a:p>
             <a:pPr>
               <a:spcAft>
-                <a:spcPts val="800"/>
-              </a:spcAft>
-              <a:defRPr sz="1600">
-                <a:solidFill>
-                  <a:srgbClr val="2C3E50"/>
-                </a:solidFill>
-              </a:defRPr>
-            </a:pPr>
-          </a:p>
-          <a:p>
-            <a:pPr>
-              <a:spcAft>
-                <a:spcPts val="800"/>
-              </a:spcAft>
-              <a:defRPr sz="1600">
-                <a:solidFill>
-                  <a:srgbClr val="2C3E50"/>
+                <a:spcPts val="400"/>
+              </a:spcAft>
+              <a:defRPr sz="1600">
+                <a:solidFill>
+                  <a:srgbClr val="34495E"/>
+                </a:solidFill>
+              </a:defRPr>
+            </a:pPr>
+          </a:p>
+          <a:p>
+            <a:pPr>
+              <a:spcAft>
+                <a:spcPts val="400"/>
+              </a:spcAft>
+              <a:defRPr sz="1600">
+                <a:solidFill>
+                  <a:srgbClr val="34495E"/>
                 </a:solidFill>
               </a:defRPr>
             </a:pPr>
@@ -3852,11 +4186,11 @@
           <a:p>
             <a:pPr>
               <a:spcAft>
-                <a:spcPts val="800"/>
-              </a:spcAft>
-              <a:defRPr sz="1600">
-                <a:solidFill>
-                  <a:srgbClr val="2C3E50"/>
+                <a:spcPts val="400"/>
+              </a:spcAft>
+              <a:defRPr sz="1600">
+                <a:solidFill>
+                  <a:srgbClr val="34495E"/>
                 </a:solidFill>
               </a:defRPr>
             </a:pPr>
@@ -3867,23 +4201,23 @@
           <a:p>
             <a:pPr>
               <a:spcAft>
-                <a:spcPts val="800"/>
-              </a:spcAft>
-              <a:defRPr sz="1600">
-                <a:solidFill>
-                  <a:srgbClr val="2C3E50"/>
-                </a:solidFill>
-              </a:defRPr>
-            </a:pPr>
-          </a:p>
-          <a:p>
-            <a:pPr>
-              <a:spcAft>
-                <a:spcPts val="800"/>
-              </a:spcAft>
-              <a:defRPr sz="1600">
-                <a:solidFill>
-                  <a:srgbClr val="2C3E50"/>
+                <a:spcPts val="400"/>
+              </a:spcAft>
+              <a:defRPr sz="1600">
+                <a:solidFill>
+                  <a:srgbClr val="34495E"/>
+                </a:solidFill>
+              </a:defRPr>
+            </a:pPr>
+          </a:p>
+          <a:p>
+            <a:pPr>
+              <a:spcAft>
+                <a:spcPts val="400"/>
+              </a:spcAft>
+              <a:defRPr sz="1600">
+                <a:solidFill>
+                  <a:srgbClr val="34495E"/>
                 </a:solidFill>
               </a:defRPr>
             </a:pPr>
@@ -3894,11 +4228,11 @@
           <a:p>
             <a:pPr>
               <a:spcAft>
-                <a:spcPts val="800"/>
-              </a:spcAft>
-              <a:defRPr sz="1600">
-                <a:solidFill>
-                  <a:srgbClr val="2C3E50"/>
+                <a:spcPts val="400"/>
+              </a:spcAft>
+              <a:defRPr sz="1600">
+                <a:solidFill>
+                  <a:srgbClr val="34495E"/>
                 </a:solidFill>
               </a:defRPr>
             </a:pPr>
@@ -3909,11 +4243,11 @@
           <a:p>
             <a:pPr>
               <a:spcAft>
-                <a:spcPts val="800"/>
-              </a:spcAft>
-              <a:defRPr sz="1600">
-                <a:solidFill>
-                  <a:srgbClr val="2C3E50"/>
+                <a:spcPts val="400"/>
+              </a:spcAft>
+              <a:defRPr sz="1600">
+                <a:solidFill>
+                  <a:srgbClr val="34495E"/>
                 </a:solidFill>
               </a:defRPr>
             </a:pPr>
@@ -3924,23 +4258,23 @@
           <a:p>
             <a:pPr>
               <a:spcAft>
-                <a:spcPts val="800"/>
-              </a:spcAft>
-              <a:defRPr sz="1600">
-                <a:solidFill>
-                  <a:srgbClr val="2C3E50"/>
-                </a:solidFill>
-              </a:defRPr>
-            </a:pPr>
-          </a:p>
-          <a:p>
-            <a:pPr>
-              <a:spcAft>
-                <a:spcPts val="800"/>
-              </a:spcAft>
-              <a:defRPr sz="1600">
-                <a:solidFill>
-                  <a:srgbClr val="2C3E50"/>
+                <a:spcPts val="400"/>
+              </a:spcAft>
+              <a:defRPr sz="1600">
+                <a:solidFill>
+                  <a:srgbClr val="34495E"/>
+                </a:solidFill>
+              </a:defRPr>
+            </a:pPr>
+          </a:p>
+          <a:p>
+            <a:pPr>
+              <a:spcAft>
+                <a:spcPts val="400"/>
+              </a:spcAft>
+              <a:defRPr sz="1600">
+                <a:solidFill>
+                  <a:srgbClr val="34495E"/>
                 </a:solidFill>
               </a:defRPr>
             </a:pPr>
@@ -3951,11 +4285,11 @@
           <a:p>
             <a:pPr>
               <a:spcAft>
-                <a:spcPts val="800"/>
-              </a:spcAft>
-              <a:defRPr sz="1600">
-                <a:solidFill>
-                  <a:srgbClr val="2C3E50"/>
+                <a:spcPts val="400"/>
+              </a:spcAft>
+              <a:defRPr sz="1600">
+                <a:solidFill>
+                  <a:srgbClr val="34495E"/>
                 </a:solidFill>
               </a:defRPr>
             </a:pPr>
@@ -3966,11 +4300,11 @@
           <a:p>
             <a:pPr>
               <a:spcAft>
-                <a:spcPts val="800"/>
-              </a:spcAft>
-              <a:defRPr sz="1600">
-                <a:solidFill>
-                  <a:srgbClr val="2C3E50"/>
+                <a:spcPts val="400"/>
+              </a:spcAft>
+              <a:defRPr sz="1600">
+                <a:solidFill>
+                  <a:srgbClr val="34495E"/>
                 </a:solidFill>
               </a:defRPr>
             </a:pPr>
@@ -3981,11 +4315,11 @@
           <a:p>
             <a:pPr>
               <a:spcAft>
-                <a:spcPts val="800"/>
-              </a:spcAft>
-              <a:defRPr sz="1600">
-                <a:solidFill>
-                  <a:srgbClr val="2C3E50"/>
+                <a:spcPts val="400"/>
+              </a:spcAft>
+              <a:defRPr sz="1600">
+                <a:solidFill>
+                  <a:srgbClr val="34495E"/>
                 </a:solidFill>
               </a:defRPr>
             </a:pPr>
@@ -4021,8 +4355,8 @@
         </p:nvSpPr>
         <p:spPr>
           <a:xfrm>
-            <a:off x="274320" y="182880"/>
-            <a:ext cx="11430000" cy="548640"/>
+            <a:off x="274320" y="137160"/>
+            <a:ext cx="11430000" cy="502920"/>
           </a:xfrm>
           <a:prstGeom prst="rect">
             <a:avLst/>
@@ -4043,7 +4377,7 @@
               </a:defRPr>
             </a:pPr>
             <a:r>
-              <a:t>Result 1: Cross-Plots Confirm Addis Is the Outlier</a:t>
+              <a:t>Result 1: Cross-Plots — Addis Is the Outlier</a:t>
             </a:r>
           </a:p>
         </p:txBody>
@@ -4064,238 +4398,14 @@
         </p:blipFill>
         <p:spPr>
           <a:xfrm>
-            <a:off x="274320" y="914400"/>
-            <a:ext cx="7772400" cy="2812286"/>
+            <a:off x="274320" y="777240"/>
+            <a:ext cx="11430000" cy="4135714"/>
           </a:xfrm>
           <a:prstGeom prst="rect">
             <a:avLst/>
           </a:prstGeom>
         </p:spPr>
       </p:pic>
-      <p:sp>
-        <p:nvSpPr>
-          <p:cNvPr id="4" name="TextBox 3"/>
-          <p:cNvSpPr txBox="1"/>
-          <p:nvPr/>
-        </p:nvSpPr>
-        <p:spPr>
-          <a:xfrm>
-            <a:off x="8229600" y="914400"/>
-            <a:ext cx="3657600" cy="5029200"/>
-          </a:xfrm>
-          <a:prstGeom prst="rect">
-            <a:avLst/>
-          </a:prstGeom>
-          <a:noFill/>
-        </p:spPr>
-        <p:txBody>
-          <a:bodyPr wrap="square">
-            <a:spAutoFit/>
-          </a:bodyPr>
-          <a:lstStyle/>
-          <a:p>
-            <a:pPr>
-              <a:spcAft>
-                <a:spcPts val="600"/>
-              </a:spcAft>
-              <a:defRPr sz="1300">
-                <a:solidFill>
-                  <a:srgbClr val="34495E"/>
-                </a:solidFill>
-              </a:defRPr>
-            </a:pPr>
-            <a:r>
-              <a:t>HIPS BC vs FTIR EC (left):</a:t>
-            </a:r>
-          </a:p>
-          <a:p>
-            <a:pPr>
-              <a:spcAft>
-                <a:spcPts val="600"/>
-              </a:spcAft>
-              <a:defRPr sz="1300">
-                <a:solidFill>
-                  <a:srgbClr val="34495E"/>
-                </a:solidFill>
-              </a:defRPr>
-            </a:pPr>
-            <a:r>
-              <a:t>  Beijing/Delhi/JPL start near zero</a:t>
-            </a:r>
-          </a:p>
-          <a:p>
-            <a:pPr>
-              <a:spcAft>
-                <a:spcPts val="600"/>
-              </a:spcAft>
-              <a:defRPr sz="1300">
-                <a:solidFill>
-                  <a:srgbClr val="34495E"/>
-                </a:solidFill>
-              </a:defRPr>
-            </a:pPr>
-            <a:r>
-              <a:t>  Addis: intercept ~2, slope ~0.3</a:t>
-            </a:r>
-          </a:p>
-          <a:p>
-            <a:pPr>
-              <a:spcAft>
-                <a:spcPts val="600"/>
-              </a:spcAft>
-              <a:defRPr sz="1300">
-                <a:solidFill>
-                  <a:srgbClr val="34495E"/>
-                </a:solidFill>
-              </a:defRPr>
-            </a:pPr>
-          </a:p>
-          <a:p>
-            <a:pPr>
-              <a:spcAft>
-                <a:spcPts val="600"/>
-              </a:spcAft>
-              <a:defRPr sz="1300">
-                <a:solidFill>
-                  <a:srgbClr val="34495E"/>
-                </a:solidFill>
-              </a:defRPr>
-            </a:pPr>
-            <a:r>
-              <a:t>Aeth vs FTIR EC (center):</a:t>
-            </a:r>
-          </a:p>
-          <a:p>
-            <a:pPr>
-              <a:spcAft>
-                <a:spcPts val="600"/>
-              </a:spcAft>
-              <a:defRPr sz="1300">
-                <a:solidFill>
-                  <a:srgbClr val="34495E"/>
-                </a:solidFill>
-              </a:defRPr>
-            </a:pPr>
-            <a:r>
-              <a:t>  Better agreement at all sites</a:t>
-            </a:r>
-          </a:p>
-          <a:p>
-            <a:pPr>
-              <a:spcAft>
-                <a:spcPts val="600"/>
-              </a:spcAft>
-              <a:defRPr sz="1300">
-                <a:solidFill>
-                  <a:srgbClr val="34495E"/>
-                </a:solidFill>
-              </a:defRPr>
-            </a:pPr>
-            <a:r>
-              <a:t>  Addis still offset but closer to 1:1</a:t>
-            </a:r>
-          </a:p>
-          <a:p>
-            <a:pPr>
-              <a:spcAft>
-                <a:spcPts val="600"/>
-              </a:spcAft>
-              <a:defRPr sz="1300">
-                <a:solidFill>
-                  <a:srgbClr val="34495E"/>
-                </a:solidFill>
-              </a:defRPr>
-            </a:pPr>
-          </a:p>
-          <a:p>
-            <a:pPr>
-              <a:spcAft>
-                <a:spcPts val="600"/>
-              </a:spcAft>
-              <a:defRPr sz="1300">
-                <a:solidFill>
-                  <a:srgbClr val="34495E"/>
-                </a:solidFill>
-              </a:defRPr>
-            </a:pPr>
-            <a:r>
-              <a:t>HIPS vs Aeth (right):</a:t>
-            </a:r>
-          </a:p>
-          <a:p>
-            <a:pPr>
-              <a:spcAft>
-                <a:spcPts val="600"/>
-              </a:spcAft>
-              <a:defRPr sz="1300">
-                <a:solidFill>
-                  <a:srgbClr val="34495E"/>
-                </a:solidFill>
-              </a:defRPr>
-            </a:pPr>
-            <a:r>
-              <a:t>  Addis compression clearly visible</a:t>
-            </a:r>
-          </a:p>
-          <a:p>
-            <a:pPr>
-              <a:spcAft>
-                <a:spcPts val="600"/>
-              </a:spcAft>
-              <a:defRPr sz="1300">
-                <a:solidFill>
-                  <a:srgbClr val="34495E"/>
-                </a:solidFill>
-              </a:defRPr>
-            </a:pPr>
-          </a:p>
-          <a:p>
-            <a:pPr>
-              <a:spcAft>
-                <a:spcPts val="600"/>
-              </a:spcAft>
-              <a:defRPr sz="1300">
-                <a:solidFill>
-                  <a:srgbClr val="34495E"/>
-                </a:solidFill>
-              </a:defRPr>
-            </a:pPr>
-            <a:r>
-              <a:t>Key: Delhi has similar concentrations</a:t>
-            </a:r>
-          </a:p>
-          <a:p>
-            <a:pPr>
-              <a:spcAft>
-                <a:spcPts val="600"/>
-              </a:spcAft>
-              <a:defRPr sz="1300">
-                <a:solidFill>
-                  <a:srgbClr val="34495E"/>
-                </a:solidFill>
-              </a:defRPr>
-            </a:pPr>
-            <a:r>
-              <a:t>to Addis but works well.</a:t>
-            </a:r>
-          </a:p>
-          <a:p>
-            <a:pPr>
-              <a:spcAft>
-                <a:spcPts val="600"/>
-              </a:spcAft>
-              <a:defRPr sz="1300">
-                <a:solidFill>
-                  <a:srgbClr val="34495E"/>
-                </a:solidFill>
-              </a:defRPr>
-            </a:pPr>
-            <a:r>
-              <a:t>-&gt; Anomaly is site-specific.</a:t>
-            </a:r>
-          </a:p>
-        </p:txBody>
-      </p:sp>
     </p:spTree>
   </p:cSld>
   <p:clrMapOvr>
@@ -4322,8 +4432,8 @@
         </p:nvSpPr>
         <p:spPr>
           <a:xfrm>
-            <a:off x="274320" y="182880"/>
-            <a:ext cx="11430000" cy="548640"/>
+            <a:off x="274320" y="137160"/>
+            <a:ext cx="11430000" cy="502920"/>
           </a:xfrm>
           <a:prstGeom prst="rect">
             <a:avLst/>
@@ -4344,14 +4454,14 @@
               </a:defRPr>
             </a:pPr>
             <a:r>
-              <a:t>Result 2: HIPS Distribution Is Compressed at Addis</a:t>
+              <a:t>Result 1b: Cross-Plot Statistics (slope, intercept, r²)</a:t>
             </a:r>
           </a:p>
         </p:txBody>
       </p:sp>
       <p:pic>
         <p:nvPicPr>
-          <p:cNvPr id="3" name="Picture 2" descr="distributions_violin.png"/>
+          <p:cNvPr id="3" name="Picture 2" descr="stats_table.png"/>
           <p:cNvPicPr>
             <a:picLocks noChangeAspect="1"/>
           </p:cNvPicPr>
@@ -4365,8 +4475,8 @@
         </p:blipFill>
         <p:spPr>
           <a:xfrm>
-            <a:off x="274320" y="914400"/>
-            <a:ext cx="7772400" cy="2405743"/>
+            <a:off x="274320" y="777240"/>
+            <a:ext cx="11430000" cy="3133069"/>
           </a:xfrm>
           <a:prstGeom prst="rect">
             <a:avLst/>
@@ -4381,8 +4491,8 @@
         </p:nvSpPr>
         <p:spPr>
           <a:xfrm>
-            <a:off x="8229600" y="914400"/>
-            <a:ext cx="3657600" cy="5029200"/>
+            <a:off x="457200" y="4754880"/>
+            <a:ext cx="10972800" cy="1828800"/>
           </a:xfrm>
           <a:prstGeom prst="rect">
             <a:avLst/>
@@ -4397,205 +4507,46 @@
           <a:p>
             <a:pPr>
               <a:spcAft>
-                <a:spcPts val="600"/>
-              </a:spcAft>
-              <a:defRPr sz="1300">
-                <a:solidFill>
-                  <a:srgbClr val="34495E"/>
-                </a:solidFill>
-              </a:defRPr>
-            </a:pPr>
-            <a:r>
-              <a:t>Beijing/Delhi/JPL:</a:t>
-            </a:r>
-          </a:p>
-          <a:p>
-            <a:pPr>
-              <a:spcAft>
-                <a:spcPts val="600"/>
-              </a:spcAft>
-              <a:defRPr sz="1300">
-                <a:solidFill>
-                  <a:srgbClr val="34495E"/>
-                </a:solidFill>
-              </a:defRPr>
-            </a:pPr>
-            <a:r>
-              <a:t>  FTIR EC and HIPS BC have</a:t>
-            </a:r>
-          </a:p>
-          <a:p>
-            <a:pPr>
-              <a:spcAft>
-                <a:spcPts val="600"/>
-              </a:spcAft>
-              <a:defRPr sz="1300">
-                <a:solidFill>
-                  <a:srgbClr val="34495E"/>
-                </a:solidFill>
-              </a:defRPr>
-            </a:pPr>
-            <a:r>
-              <a:t>  comparable distributions</a:t>
-            </a:r>
-          </a:p>
-          <a:p>
-            <a:pPr>
-              <a:spcAft>
-                <a:spcPts val="600"/>
-              </a:spcAft>
-              <a:defRPr sz="1300">
-                <a:solidFill>
-                  <a:srgbClr val="34495E"/>
-                </a:solidFill>
-              </a:defRPr>
-            </a:pPr>
-          </a:p>
-          <a:p>
-            <a:pPr>
-              <a:spcAft>
-                <a:spcPts val="600"/>
-              </a:spcAft>
-              <a:defRPr sz="1300">
-                <a:solidFill>
-                  <a:srgbClr val="34495E"/>
-                </a:solidFill>
-              </a:defRPr>
-            </a:pPr>
-            <a:r>
-              <a:t>Addis Ababa:</a:t>
-            </a:r>
-          </a:p>
-          <a:p>
-            <a:pPr>
-              <a:spcAft>
-                <a:spcPts val="600"/>
-              </a:spcAft>
-              <a:defRPr sz="1300">
-                <a:solidFill>
-                  <a:srgbClr val="34495E"/>
-                </a:solidFill>
-              </a:defRPr>
-            </a:pPr>
-            <a:r>
-              <a:t>  HIPS BC squeezed to ~2-4 ug/m3</a:t>
-            </a:r>
-          </a:p>
-          <a:p>
-            <a:pPr>
-              <a:spcAft>
-                <a:spcPts val="600"/>
-              </a:spcAft>
-              <a:defRPr sz="1300">
-                <a:solidFill>
-                  <a:srgbClr val="34495E"/>
-                </a:solidFill>
-              </a:defRPr>
-            </a:pPr>
-            <a:r>
-              <a:t>  FTIR EC spans ~2-15 ug/m3</a:t>
-            </a:r>
-          </a:p>
-          <a:p>
-            <a:pPr>
-              <a:spcAft>
-                <a:spcPts val="600"/>
-              </a:spcAft>
-              <a:defRPr sz="1300">
-                <a:solidFill>
-                  <a:srgbClr val="34495E"/>
-                </a:solidFill>
-              </a:defRPr>
-            </a:pPr>
-            <a:r>
-              <a:t>  Aeth spans ~2-17 ug/m3</a:t>
-            </a:r>
-          </a:p>
-          <a:p>
-            <a:pPr>
-              <a:spcAft>
-                <a:spcPts val="600"/>
-              </a:spcAft>
-              <a:defRPr sz="1300">
-                <a:solidFill>
-                  <a:srgbClr val="34495E"/>
-                </a:solidFill>
-              </a:defRPr>
-            </a:pPr>
-          </a:p>
-          <a:p>
-            <a:pPr>
-              <a:spcAft>
-                <a:spcPts val="600"/>
-              </a:spcAft>
-              <a:defRPr sz="1300">
-                <a:solidFill>
-                  <a:srgbClr val="34495E"/>
-                </a:solidFill>
-              </a:defRPr>
-            </a:pPr>
-            <a:r>
-              <a:t>This compression + offset cannot</a:t>
-            </a:r>
-          </a:p>
-          <a:p>
-            <a:pPr>
-              <a:spcAft>
-                <a:spcPts val="600"/>
-              </a:spcAft>
-              <a:defRPr sz="1300">
-                <a:solidFill>
-                  <a:srgbClr val="34495E"/>
-                </a:solidFill>
-              </a:defRPr>
-            </a:pPr>
-            <a:r>
-              <a:t>be fixed by changing MAC alone.</a:t>
-            </a:r>
-          </a:p>
-          <a:p>
-            <a:pPr>
-              <a:spcAft>
-                <a:spcPts val="600"/>
-              </a:spcAft>
-              <a:defRPr sz="1300">
-                <a:solidFill>
-                  <a:srgbClr val="34495E"/>
-                </a:solidFill>
-              </a:defRPr>
-            </a:pPr>
-            <a:r>
-              <a:t>Baseline subtraction alone does not</a:t>
-            </a:r>
-          </a:p>
-          <a:p>
-            <a:pPr>
-              <a:spcAft>
-                <a:spcPts val="600"/>
-              </a:spcAft>
-              <a:defRPr sz="1300">
-                <a:solidFill>
-                  <a:srgbClr val="34495E"/>
-                </a:solidFill>
-              </a:defRPr>
-            </a:pPr>
-            <a:r>
-              <a:t>fix the slope; fixing the slope</a:t>
-            </a:r>
-          </a:p>
-          <a:p>
-            <a:pPr>
-              <a:spcAft>
-                <a:spcPts val="600"/>
-              </a:spcAft>
-              <a:defRPr sz="1300">
-                <a:solidFill>
-                  <a:srgbClr val="34495E"/>
-                </a:solidFill>
-              </a:defRPr>
-            </a:pPr>
-            <a:r>
-              <a:t>still leaves a large intercept.</a:t>
+                <a:spcPts val="400"/>
+              </a:spcAft>
+              <a:defRPr sz="1400">
+                <a:solidFill>
+                  <a:srgbClr val="34495E"/>
+                </a:solidFill>
+              </a:defRPr>
+            </a:pPr>
+            <a:r>
+              <a:t>Addis (orange rows): slope ~0.3, intercept ~2.0 for HIPS vs FTIR EC — far from 1:1</a:t>
+            </a:r>
+          </a:p>
+          <a:p>
+            <a:pPr>
+              <a:spcAft>
+                <a:spcPts val="400"/>
+              </a:spcAft>
+              <a:defRPr sz="1400">
+                <a:solidFill>
+                  <a:srgbClr val="34495E"/>
+                </a:solidFill>
+              </a:defRPr>
+            </a:pPr>
+            <a:r>
+              <a:t>Beijing/JPL: slopes closer to 1:1, intercepts near zero</a:t>
+            </a:r>
+          </a:p>
+          <a:p>
+            <a:pPr>
+              <a:spcAft>
+                <a:spcPts val="400"/>
+              </a:spcAft>
+              <a:defRPr sz="1400">
+                <a:solidFill>
+                  <a:srgbClr val="34495E"/>
+                </a:solidFill>
+              </a:defRPr>
+            </a:pPr>
+            <a:r>
+              <a:t>Delhi: high concentration but works well — rules out concentration as the cause</a:t>
             </a:r>
           </a:p>
         </p:txBody>
@@ -4626,8 +4577,8 @@
         </p:nvSpPr>
         <p:spPr>
           <a:xfrm>
-            <a:off x="274320" y="182880"/>
-            <a:ext cx="11430000" cy="548640"/>
+            <a:off x="274320" y="137160"/>
+            <a:ext cx="11430000" cy="502920"/>
           </a:xfrm>
           <a:prstGeom prst="rect">
             <a:avLst/>
@@ -4648,14 +4599,14 @@
               </a:defRPr>
             </a:pPr>
             <a:r>
-              <a:t>Result 2b: Histograms by Site and Method</a:t>
+              <a:t>Result 2: HIPS Distribution Is Compressed at Addis</a:t>
             </a:r>
           </a:p>
         </p:txBody>
       </p:sp>
       <p:pic>
         <p:nvPicPr>
-          <p:cNvPr id="3" name="Picture 2" descr="distributions_histogram.png"/>
+          <p:cNvPr id="3" name="Picture 2" descr="distributions_violin.png"/>
           <p:cNvPicPr>
             <a:picLocks noChangeAspect="1"/>
           </p:cNvPicPr>
@@ -4669,14 +4620,82 @@
         </p:blipFill>
         <p:spPr>
           <a:xfrm>
-            <a:off x="274320" y="914400"/>
-            <a:ext cx="11430000" cy="12956843"/>
+            <a:off x="274320" y="777240"/>
+            <a:ext cx="11430000" cy="3537857"/>
           </a:xfrm>
           <a:prstGeom prst="rect">
             <a:avLst/>
           </a:prstGeom>
         </p:spPr>
       </p:pic>
+      <p:sp>
+        <p:nvSpPr>
+          <p:cNvPr id="4" name="TextBox 3"/>
+          <p:cNvSpPr txBox="1"/>
+          <p:nvPr/>
+        </p:nvSpPr>
+        <p:spPr>
+          <a:xfrm>
+            <a:off x="457200" y="4389120"/>
+            <a:ext cx="10972800" cy="2011680"/>
+          </a:xfrm>
+          <a:prstGeom prst="rect">
+            <a:avLst/>
+          </a:prstGeom>
+          <a:noFill/>
+        </p:spPr>
+        <p:txBody>
+          <a:bodyPr wrap="square">
+            <a:spAutoFit/>
+          </a:bodyPr>
+          <a:lstStyle/>
+          <a:p>
+            <a:pPr>
+              <a:spcAft>
+                <a:spcPts val="400"/>
+              </a:spcAft>
+              <a:defRPr sz="1400">
+                <a:solidFill>
+                  <a:srgbClr val="34495E"/>
+                </a:solidFill>
+              </a:defRPr>
+            </a:pPr>
+            <a:r>
+              <a:t>Beijing/Delhi/JPL: FTIR EC, HIPS BC, and Aeth have comparable distributions</a:t>
+            </a:r>
+          </a:p>
+          <a:p>
+            <a:pPr>
+              <a:spcAft>
+                <a:spcPts val="400"/>
+              </a:spcAft>
+              <a:defRPr sz="1400">
+                <a:solidFill>
+                  <a:srgbClr val="34495E"/>
+                </a:solidFill>
+              </a:defRPr>
+            </a:pPr>
+            <a:r>
+              <a:t>Addis: HIPS BC squeezed into narrow range (~2-4 ug/m3) while FTIR EC and Aeth span ~2-15 ug/m3</a:t>
+            </a:r>
+          </a:p>
+          <a:p>
+            <a:pPr>
+              <a:spcAft>
+                <a:spcPts val="400"/>
+              </a:spcAft>
+              <a:defRPr sz="1400">
+                <a:solidFill>
+                  <a:srgbClr val="34495E"/>
+                </a:solidFill>
+              </a:defRPr>
+            </a:pPr>
+            <a:r>
+              <a:t>This compression + offset cannot be fixed by changing MAC alone</a:t>
+            </a:r>
+          </a:p>
+        </p:txBody>
+      </p:sp>
     </p:spTree>
   </p:cSld>
   <p:clrMapOvr>
@@ -4703,8 +4722,8 @@
         </p:nvSpPr>
         <p:spPr>
           <a:xfrm>
-            <a:off x="274320" y="182880"/>
-            <a:ext cx="11430000" cy="640080"/>
+            <a:off x="274320" y="137160"/>
+            <a:ext cx="11430000" cy="502920"/>
           </a:xfrm>
           <a:prstGeom prst="rect">
             <a:avLst/>
@@ -4718,28 +4737,52 @@
           <a:lstStyle/>
           <a:p>
             <a:pPr>
-              <a:defRPr sz="2400" b="1">
+              <a:defRPr sz="2200" b="1">
                 <a:solidFill>
                   <a:srgbClr val="2C3E50"/>
                 </a:solidFill>
               </a:defRPr>
             </a:pPr>
             <a:r>
-              <a:t>Result 3: Low-Concentration Sites — Analysis Complete</a:t>
-            </a:r>
-          </a:p>
-        </p:txBody>
-      </p:sp>
-      <p:sp>
-        <p:nvSpPr>
-          <p:cNvPr id="3" name="TextBox 2"/>
+              <a:t>Result 2b: Detailed Histograms — EC, HIPS, Aeth by Site</a:t>
+            </a:r>
+          </a:p>
+        </p:txBody>
+      </p:sp>
+      <p:pic>
+        <p:nvPicPr>
+          <p:cNvPr id="3" name="Picture 2" descr="distributions_histogram.png"/>
+          <p:cNvPicPr>
+            <a:picLocks noChangeAspect="1"/>
+          </p:cNvPicPr>
+          <p:nvPr/>
+        </p:nvPicPr>
+        <p:blipFill>
+          <a:blip r:embed="rId2"/>
+          <a:stretch>
+            <a:fillRect/>
+          </a:stretch>
+        </p:blipFill>
+        <p:spPr>
+          <a:xfrm>
+            <a:off x="3200400" y="777240"/>
+            <a:ext cx="5081873" cy="5760720"/>
+          </a:xfrm>
+          <a:prstGeom prst="rect">
+            <a:avLst/>
+          </a:prstGeom>
+        </p:spPr>
+      </p:pic>
+      <p:sp>
+        <p:nvSpPr>
+          <p:cNvPr id="4" name="TextBox 3"/>
           <p:cNvSpPr txBox="1"/>
           <p:nvPr/>
         </p:nvSpPr>
         <p:spPr>
           <a:xfrm>
-            <a:off x="457200" y="914400"/>
-            <a:ext cx="10972800" cy="5486400"/>
+            <a:off x="274320" y="914400"/>
+            <a:ext cx="2743200" cy="5029200"/>
           </a:xfrm>
           <a:prstGeom prst="rect">
             <a:avLst/>
@@ -4754,226 +4797,160 @@
           <a:p>
             <a:pPr>
               <a:spcAft>
-                <a:spcPts val="800"/>
-              </a:spcAft>
-              <a:defRPr sz="1600">
-                <a:solidFill>
-                  <a:srgbClr val="2C3E50"/>
-                </a:solidFill>
-              </a:defRPr>
-            </a:pPr>
-            <a:r>
-              <a:t>Beijing + JPL (252 paired filter samples):</a:t>
-            </a:r>
-          </a:p>
-          <a:p>
-            <a:pPr>
-              <a:spcAft>
-                <a:spcPts val="800"/>
-              </a:spcAft>
-              <a:defRPr sz="1600">
-                <a:solidFill>
-                  <a:srgbClr val="2C3E50"/>
-                </a:solidFill>
-              </a:defRPr>
-            </a:pPr>
-          </a:p>
-          <a:p>
-            <a:pPr>
-              <a:spcAft>
-                <a:spcPts val="800"/>
-              </a:spcAft>
-              <a:defRPr sz="1600">
-                <a:solidFill>
-                  <a:srgbClr val="2C3E50"/>
-                </a:solidFill>
-              </a:defRPr>
-            </a:pPr>
-            <a:r>
-              <a:t>  1. HIPS and FTIR EC match extremely well (slope ~ 1.0 with MAC = 10)</a:t>
-            </a:r>
-          </a:p>
-          <a:p>
-            <a:pPr>
-              <a:spcAft>
-                <a:spcPts val="800"/>
-              </a:spcAft>
-              <a:defRPr sz="1600">
-                <a:solidFill>
-                  <a:srgbClr val="2C3E50"/>
-                </a:solidFill>
-              </a:defRPr>
-            </a:pPr>
-          </a:p>
-          <a:p>
-            <a:pPr>
-              <a:spcAft>
-                <a:spcPts val="800"/>
-              </a:spcAft>
-              <a:defRPr sz="1600">
-                <a:solidFill>
-                  <a:srgbClr val="2C3E50"/>
-                </a:solidFill>
-              </a:defRPr>
-            </a:pPr>
-            <a:r>
-              <a:t>  2. Aethalometer correlation is weaker but acceptable given</a:t>
-            </a:r>
-          </a:p>
-          <a:p>
-            <a:pPr>
-              <a:spcAft>
-                <a:spcPts val="800"/>
-              </a:spcAft>
-              <a:defRPr sz="1600">
-                <a:solidFill>
-                  <a:srgbClr val="2C3E50"/>
-                </a:solidFill>
-              </a:defRPr>
-            </a:pPr>
-            <a:r>
-              <a:t>     measurement precision limitations at low concentrations</a:t>
-            </a:r>
-          </a:p>
-          <a:p>
-            <a:pPr>
-              <a:spcAft>
-                <a:spcPts val="800"/>
-              </a:spcAft>
-              <a:defRPr sz="1600">
-                <a:solidFill>
-                  <a:srgbClr val="2C3E50"/>
-                </a:solidFill>
-              </a:defRPr>
-            </a:pPr>
-          </a:p>
-          <a:p>
-            <a:pPr>
-              <a:spcAft>
-                <a:spcPts val="800"/>
-              </a:spcAft>
-              <a:defRPr sz="1600">
-                <a:solidFill>
-                  <a:srgbClr val="2C3E50"/>
-                </a:solidFill>
-              </a:defRPr>
-            </a:pPr>
-            <a:r>
-              <a:t>  3. Iron (evaluated by both concentration and ratio)</a:t>
-            </a:r>
-          </a:p>
-          <a:p>
-            <a:pPr>
-              <a:spcAft>
-                <a:spcPts val="800"/>
-              </a:spcAft>
-              <a:defRPr sz="1600">
-                <a:solidFill>
-                  <a:srgbClr val="2C3E50"/>
-                </a:solidFill>
-              </a:defRPr>
-            </a:pPr>
-            <a:r>
-              <a:t>     does NOT significantly impact measurements at these sites</a:t>
-            </a:r>
-          </a:p>
-          <a:p>
-            <a:pPr>
-              <a:spcAft>
-                <a:spcPts val="800"/>
-              </a:spcAft>
-              <a:defRPr sz="1600">
-                <a:solidFill>
-                  <a:srgbClr val="2C3E50"/>
-                </a:solidFill>
-              </a:defRPr>
-            </a:pPr>
-          </a:p>
-          <a:p>
-            <a:pPr>
-              <a:spcAft>
-                <a:spcPts val="800"/>
-              </a:spcAft>
-              <a:defRPr sz="1600">
-                <a:solidFill>
-                  <a:srgbClr val="2C3E50"/>
-                </a:solidFill>
-              </a:defRPr>
-            </a:pPr>
-            <a:r>
-              <a:t>  4. All three measurement methods produce reasonably similar EC values</a:t>
-            </a:r>
-          </a:p>
-          <a:p>
-            <a:pPr>
-              <a:spcAft>
-                <a:spcPts val="800"/>
-              </a:spcAft>
-              <a:defRPr sz="1600">
-                <a:solidFill>
-                  <a:srgbClr val="2C3E50"/>
-                </a:solidFill>
-              </a:defRPr>
-            </a:pPr>
-          </a:p>
-          <a:p>
-            <a:pPr>
-              <a:spcAft>
-                <a:spcPts val="800"/>
-              </a:spcAft>
-              <a:defRPr sz="1600">
-                <a:solidFill>
-                  <a:srgbClr val="2C3E50"/>
-                </a:solidFill>
-              </a:defRPr>
-            </a:pPr>
-            <a:r>
-              <a:t>Practical implication:</a:t>
-            </a:r>
-          </a:p>
-          <a:p>
-            <a:pPr>
-              <a:spcAft>
-                <a:spcPts val="800"/>
-              </a:spcAft>
-              <a:defRPr sz="1600">
-                <a:solidFill>
-                  <a:srgbClr val="2C3E50"/>
-                </a:solidFill>
-              </a:defRPr>
-            </a:pPr>
-            <a:r>
-              <a:t>  At low-concentration sites, any of the three methods gives</a:t>
-            </a:r>
-          </a:p>
-          <a:p>
-            <a:pPr>
-              <a:spcAft>
-                <a:spcPts val="800"/>
-              </a:spcAft>
-              <a:defRPr sz="1600">
-                <a:solidFill>
-                  <a:srgbClr val="2C3E50"/>
-                </a:solidFill>
-              </a:defRPr>
-            </a:pPr>
-            <a:r>
-              <a:t>  reasonable EC values. Aethalometer is less ideal but acceptable</a:t>
-            </a:r>
-          </a:p>
-          <a:p>
-            <a:pPr>
-              <a:spcAft>
-                <a:spcPts val="800"/>
-              </a:spcAft>
-              <a:defRPr sz="1600">
-                <a:solidFill>
-                  <a:srgbClr val="2C3E50"/>
-                </a:solidFill>
-              </a:defRPr>
-            </a:pPr>
-            <a:r>
-              <a:t>  for high time resolution needs.</a:t>
+                <a:spcPts val="400"/>
+              </a:spcAft>
+              <a:defRPr sz="1200">
+                <a:solidFill>
+                  <a:srgbClr val="34495E"/>
+                </a:solidFill>
+              </a:defRPr>
+            </a:pPr>
+            <a:r>
+              <a:t>Each row = one site</a:t>
+            </a:r>
+          </a:p>
+          <a:p>
+            <a:pPr>
+              <a:spcAft>
+                <a:spcPts val="400"/>
+              </a:spcAft>
+              <a:defRPr sz="1200">
+                <a:solidFill>
+                  <a:srgbClr val="34495E"/>
+                </a:solidFill>
+              </a:defRPr>
+            </a:pPr>
+            <a:r>
+              <a:t>Each column = one method</a:t>
+            </a:r>
+          </a:p>
+          <a:p>
+            <a:pPr>
+              <a:spcAft>
+                <a:spcPts val="400"/>
+              </a:spcAft>
+              <a:defRPr sz="1200">
+                <a:solidFill>
+                  <a:srgbClr val="34495E"/>
+                </a:solidFill>
+              </a:defRPr>
+            </a:pPr>
+          </a:p>
+          <a:p>
+            <a:pPr>
+              <a:spcAft>
+                <a:spcPts val="400"/>
+              </a:spcAft>
+              <a:defRPr sz="1200">
+                <a:solidFill>
+                  <a:srgbClr val="34495E"/>
+                </a:solidFill>
+              </a:defRPr>
+            </a:pPr>
+            <a:r>
+              <a:t>Note the Addis row:</a:t>
+            </a:r>
+          </a:p>
+          <a:p>
+            <a:pPr>
+              <a:spcAft>
+                <a:spcPts val="400"/>
+              </a:spcAft>
+              <a:defRPr sz="1200">
+                <a:solidFill>
+                  <a:srgbClr val="34495E"/>
+                </a:solidFill>
+              </a:defRPr>
+            </a:pPr>
+            <a:r>
+              <a:t>  FTIR EC peaks ~4-5</a:t>
+            </a:r>
+          </a:p>
+          <a:p>
+            <a:pPr>
+              <a:spcAft>
+                <a:spcPts val="400"/>
+              </a:spcAft>
+              <a:defRPr sz="1200">
+                <a:solidFill>
+                  <a:srgbClr val="34495E"/>
+                </a:solidFill>
+              </a:defRPr>
+            </a:pPr>
+            <a:r>
+              <a:t>  HIPS BC peaks ~2-3</a:t>
+            </a:r>
+          </a:p>
+          <a:p>
+            <a:pPr>
+              <a:spcAft>
+                <a:spcPts val="400"/>
+              </a:spcAft>
+              <a:defRPr sz="1200">
+                <a:solidFill>
+                  <a:srgbClr val="34495E"/>
+                </a:solidFill>
+              </a:defRPr>
+            </a:pPr>
+            <a:r>
+              <a:t>  Aeth peaks ~5-7</a:t>
+            </a:r>
+          </a:p>
+          <a:p>
+            <a:pPr>
+              <a:spcAft>
+                <a:spcPts val="400"/>
+              </a:spcAft>
+              <a:defRPr sz="1200">
+                <a:solidFill>
+                  <a:srgbClr val="34495E"/>
+                </a:solidFill>
+              </a:defRPr>
+            </a:pPr>
+          </a:p>
+          <a:p>
+            <a:pPr>
+              <a:spcAft>
+                <a:spcPts val="400"/>
+              </a:spcAft>
+              <a:defRPr sz="1200">
+                <a:solidFill>
+                  <a:srgbClr val="34495E"/>
+                </a:solidFill>
+              </a:defRPr>
+            </a:pPr>
+            <a:r>
+              <a:t>Median (dashed black)</a:t>
+            </a:r>
+          </a:p>
+          <a:p>
+            <a:pPr>
+              <a:spcAft>
+                <a:spcPts val="400"/>
+              </a:spcAft>
+              <a:defRPr sz="1200">
+                <a:solidFill>
+                  <a:srgbClr val="34495E"/>
+                </a:solidFill>
+              </a:defRPr>
+            </a:pPr>
+            <a:r>
+              <a:t>Mean (dotted red)</a:t>
+            </a:r>
+          </a:p>
+          <a:p>
+            <a:pPr>
+              <a:spcAft>
+                <a:spcPts val="400"/>
+              </a:spcAft>
+              <a:defRPr sz="1200">
+                <a:solidFill>
+                  <a:srgbClr val="34495E"/>
+                </a:solidFill>
+              </a:defRPr>
+            </a:pPr>
+            <a:r>
+              <a:t>std shown in title</a:t>
             </a:r>
           </a:p>
         </p:txBody>
@@ -5004,8 +4981,8 @@
         </p:nvSpPr>
         <p:spPr>
           <a:xfrm>
-            <a:off x="274320" y="182880"/>
-            <a:ext cx="11430000" cy="640080"/>
+            <a:off x="274320" y="137160"/>
+            <a:ext cx="11430000" cy="502920"/>
           </a:xfrm>
           <a:prstGeom prst="rect">
             <a:avLst/>
@@ -5019,14 +4996,14 @@
           <a:lstStyle/>
           <a:p>
             <a:pPr>
-              <a:defRPr sz="2400" b="1">
+              <a:defRPr sz="2200" b="1">
                 <a:solidFill>
                   <a:srgbClr val="2C3E50"/>
                 </a:solidFill>
               </a:defRPr>
             </a:pPr>
             <a:r>
-              <a:t>Result 4: High-Concentration Sites — The Addis Problem</a:t>
+              <a:t>Result 3: Low-Concentration Sites — Complete</a:t>
             </a:r>
           </a:p>
         </p:txBody>
@@ -5039,8 +5016,8 @@
         </p:nvSpPr>
         <p:spPr>
           <a:xfrm>
-            <a:off x="457200" y="914400"/>
-            <a:ext cx="10972800" cy="5486400"/>
+            <a:off x="457200" y="777240"/>
+            <a:ext cx="10972800" cy="5669280"/>
           </a:xfrm>
           <a:prstGeom prst="rect">
             <a:avLst/>
@@ -5055,205 +5032,211 @@
           <a:p>
             <a:pPr>
               <a:spcAft>
-                <a:spcPts val="800"/>
-              </a:spcAft>
-              <a:defRPr sz="1600">
-                <a:solidFill>
-                  <a:srgbClr val="2C3E50"/>
-                </a:solidFill>
-              </a:defRPr>
-            </a:pPr>
-            <a:r>
-              <a:t>Delhi (63 paired samples): Works well despite high concentrations.</a:t>
-            </a:r>
-          </a:p>
-          <a:p>
-            <a:pPr>
-              <a:spcAft>
-                <a:spcPts val="800"/>
-              </a:spcAft>
-              <a:defRPr sz="1600">
-                <a:solidFill>
-                  <a:srgbClr val="2C3E50"/>
-                </a:solidFill>
-              </a:defRPr>
-            </a:pPr>
-            <a:r>
-              <a:t>  -&gt; Concentration alone does not explain the discrepancy.</a:t>
-            </a:r>
-          </a:p>
-          <a:p>
-            <a:pPr>
-              <a:spcAft>
-                <a:spcPts val="800"/>
-              </a:spcAft>
-              <a:defRPr sz="1600">
-                <a:solidFill>
-                  <a:srgbClr val="2C3E50"/>
-                </a:solidFill>
-              </a:defRPr>
-            </a:pPr>
-          </a:p>
-          <a:p>
-            <a:pPr>
-              <a:spcAft>
-                <a:spcPts val="800"/>
-              </a:spcAft>
-              <a:defRPr sz="1600">
-                <a:solidFill>
-                  <a:srgbClr val="2C3E50"/>
-                </a:solidFill>
-              </a:defRPr>
-            </a:pPr>
-            <a:r>
-              <a:t>Addis Ababa (190 paired samples): Persistent anomaly.</a:t>
-            </a:r>
-          </a:p>
-          <a:p>
-            <a:pPr>
-              <a:spcAft>
-                <a:spcPts val="800"/>
-              </a:spcAft>
-              <a:defRPr sz="1600">
-                <a:solidFill>
-                  <a:srgbClr val="2C3E50"/>
-                </a:solidFill>
-              </a:defRPr>
-            </a:pPr>
-            <a:r>
-              <a:t>  - Intercept: ~2 ug/m3 (no other site shows this)</a:t>
-            </a:r>
-          </a:p>
-          <a:p>
-            <a:pPr>
-              <a:spcAft>
-                <a:spcPts val="800"/>
-              </a:spcAft>
-              <a:defRPr sz="1600">
-                <a:solidFill>
-                  <a:srgbClr val="2C3E50"/>
-                </a:solidFill>
-              </a:defRPr>
-            </a:pPr>
-            <a:r>
-              <a:t>  - Slope: ~0.3 (should be ~1.0)</a:t>
-            </a:r>
-          </a:p>
-          <a:p>
-            <a:pPr>
-              <a:spcAft>
-                <a:spcPts val="800"/>
-              </a:spcAft>
-              <a:defRPr sz="1600">
-                <a:solidFill>
-                  <a:srgbClr val="2C3E50"/>
-                </a:solidFill>
-              </a:defRPr>
-            </a:pPr>
-            <a:r>
-              <a:t>  - Cannot distinguish by season — problem is year-round</a:t>
-            </a:r>
-          </a:p>
-          <a:p>
-            <a:pPr>
-              <a:spcAft>
-                <a:spcPts val="800"/>
-              </a:spcAft>
-              <a:defRPr sz="1600">
-                <a:solidFill>
-                  <a:srgbClr val="2C3E50"/>
-                </a:solidFill>
-              </a:defRPr>
-            </a:pPr>
-            <a:r>
-              <a:t>  - Cannot distinguish by source type — all combustion sources</a:t>
-            </a:r>
-          </a:p>
-          <a:p>
-            <a:pPr>
-              <a:spcAft>
-                <a:spcPts val="800"/>
-              </a:spcAft>
-              <a:defRPr sz="1600">
-                <a:solidFill>
-                  <a:srgbClr val="2C3E50"/>
-                </a:solidFill>
-              </a:defRPr>
-            </a:pPr>
-            <a:r>
-              <a:t>    (charcoal, wood, fossil fuel) show similar slopes</a:t>
-            </a:r>
-          </a:p>
-          <a:p>
-            <a:pPr>
-              <a:spcAft>
-                <a:spcPts val="800"/>
-              </a:spcAft>
-              <a:defRPr sz="1600">
-                <a:solidFill>
-                  <a:srgbClr val="2C3E50"/>
-                </a:solidFill>
-              </a:defRPr>
-            </a:pPr>
-          </a:p>
-          <a:p>
-            <a:pPr>
-              <a:spcAft>
-                <a:spcPts val="800"/>
-              </a:spcAft>
-              <a:defRPr sz="1600">
-                <a:solidFill>
-                  <a:srgbClr val="2C3E50"/>
-                </a:solidFill>
-              </a:defRPr>
-            </a:pPr>
-            <a:r>
-              <a:t>The anomaly has two DISTINCT co-occurring issues:</a:t>
-            </a:r>
-          </a:p>
-          <a:p>
-            <a:pPr>
-              <a:spcAft>
-                <a:spcPts val="800"/>
-              </a:spcAft>
-              <a:defRPr sz="1600">
-                <a:solidFill>
-                  <a:srgbClr val="2C3E50"/>
-                </a:solidFill>
-              </a:defRPr>
-            </a:pPr>
-            <a:r>
-              <a:t>  1. OFFSET: Large positive intercept that baseline subtraction alone</a:t>
-            </a:r>
-          </a:p>
-          <a:p>
-            <a:pPr>
-              <a:spcAft>
-                <a:spcPts val="800"/>
-              </a:spcAft>
-              <a:defRPr sz="1600">
-                <a:solidFill>
-                  <a:srgbClr val="2C3E50"/>
-                </a:solidFill>
-              </a:defRPr>
-            </a:pPr>
-            <a:r>
-              <a:t>     does not fix</a:t>
-            </a:r>
-          </a:p>
-          <a:p>
-            <a:pPr>
-              <a:spcAft>
-                <a:spcPts val="800"/>
-              </a:spcAft>
-              <a:defRPr sz="1600">
-                <a:solidFill>
-                  <a:srgbClr val="2C3E50"/>
-                </a:solidFill>
-              </a:defRPr>
-            </a:pPr>
-            <a:r>
-              <a:t>  2. COMPRESSION: HIPS has much lower variability than EC or aeth</a:t>
+                <a:spcPts val="400"/>
+              </a:spcAft>
+              <a:defRPr sz="1600">
+                <a:solidFill>
+                  <a:srgbClr val="34495E"/>
+                </a:solidFill>
+              </a:defRPr>
+            </a:pPr>
+            <a:r>
+              <a:t>Beijing + JPL (252 paired filter samples):</a:t>
+            </a:r>
+          </a:p>
+          <a:p>
+            <a:pPr>
+              <a:spcAft>
+                <a:spcPts val="400"/>
+              </a:spcAft>
+              <a:defRPr sz="1600">
+                <a:solidFill>
+                  <a:srgbClr val="34495E"/>
+                </a:solidFill>
+              </a:defRPr>
+            </a:pPr>
+          </a:p>
+          <a:p>
+            <a:pPr>
+              <a:spcAft>
+                <a:spcPts val="400"/>
+              </a:spcAft>
+              <a:defRPr sz="1600">
+                <a:solidFill>
+                  <a:srgbClr val="34495E"/>
+                </a:solidFill>
+              </a:defRPr>
+            </a:pPr>
+            <a:r>
+              <a:t>  1. HIPS and FTIR EC match extremely well (slope ~ 1.0 with MAC = 10)</a:t>
+            </a:r>
+          </a:p>
+          <a:p>
+            <a:pPr>
+              <a:spcAft>
+                <a:spcPts val="400"/>
+              </a:spcAft>
+              <a:defRPr sz="1600">
+                <a:solidFill>
+                  <a:srgbClr val="34495E"/>
+                </a:solidFill>
+              </a:defRPr>
+            </a:pPr>
+          </a:p>
+          <a:p>
+            <a:pPr>
+              <a:spcAft>
+                <a:spcPts val="400"/>
+              </a:spcAft>
+              <a:defRPr sz="1600">
+                <a:solidFill>
+                  <a:srgbClr val="34495E"/>
+                </a:solidFill>
+              </a:defRPr>
+            </a:pPr>
+            <a:r>
+              <a:t>  2. Aethalometer correlation is weaker but acceptable</a:t>
+            </a:r>
+          </a:p>
+          <a:p>
+            <a:pPr>
+              <a:spcAft>
+                <a:spcPts val="400"/>
+              </a:spcAft>
+              <a:defRPr sz="1600">
+                <a:solidFill>
+                  <a:srgbClr val="34495E"/>
+                </a:solidFill>
+              </a:defRPr>
+            </a:pPr>
+            <a:r>
+              <a:t>     (measurement precision limited at low concentrations)</a:t>
+            </a:r>
+          </a:p>
+          <a:p>
+            <a:pPr>
+              <a:spcAft>
+                <a:spcPts val="400"/>
+              </a:spcAft>
+              <a:defRPr sz="1600">
+                <a:solidFill>
+                  <a:srgbClr val="34495E"/>
+                </a:solidFill>
+              </a:defRPr>
+            </a:pPr>
+          </a:p>
+          <a:p>
+            <a:pPr>
+              <a:spcAft>
+                <a:spcPts val="400"/>
+              </a:spcAft>
+              <a:defRPr sz="1600">
+                <a:solidFill>
+                  <a:srgbClr val="34495E"/>
+                </a:solidFill>
+              </a:defRPr>
+            </a:pPr>
+            <a:r>
+              <a:t>  3. Iron (by both concentration and ratio) does NOT significantly</a:t>
+            </a:r>
+          </a:p>
+          <a:p>
+            <a:pPr>
+              <a:spcAft>
+                <a:spcPts val="400"/>
+              </a:spcAft>
+              <a:defRPr sz="1600">
+                <a:solidFill>
+                  <a:srgbClr val="34495E"/>
+                </a:solidFill>
+              </a:defRPr>
+            </a:pPr>
+            <a:r>
+              <a:t>     impact measurements at these sites</a:t>
+            </a:r>
+          </a:p>
+          <a:p>
+            <a:pPr>
+              <a:spcAft>
+                <a:spcPts val="400"/>
+              </a:spcAft>
+              <a:defRPr sz="1600">
+                <a:solidFill>
+                  <a:srgbClr val="34495E"/>
+                </a:solidFill>
+              </a:defRPr>
+            </a:pPr>
+          </a:p>
+          <a:p>
+            <a:pPr>
+              <a:spcAft>
+                <a:spcPts val="400"/>
+              </a:spcAft>
+              <a:defRPr sz="1600">
+                <a:solidFill>
+                  <a:srgbClr val="34495E"/>
+                </a:solidFill>
+              </a:defRPr>
+            </a:pPr>
+            <a:r>
+              <a:t>  4. All three methods produce reasonably similar EC values</a:t>
+            </a:r>
+          </a:p>
+          <a:p>
+            <a:pPr>
+              <a:spcAft>
+                <a:spcPts val="400"/>
+              </a:spcAft>
+              <a:defRPr sz="1600">
+                <a:solidFill>
+                  <a:srgbClr val="34495E"/>
+                </a:solidFill>
+              </a:defRPr>
+            </a:pPr>
+          </a:p>
+          <a:p>
+            <a:pPr>
+              <a:spcAft>
+                <a:spcPts val="400"/>
+              </a:spcAft>
+              <a:defRPr sz="1600">
+                <a:solidFill>
+                  <a:srgbClr val="34495E"/>
+                </a:solidFill>
+              </a:defRPr>
+            </a:pPr>
+            <a:r>
+              <a:t>Practical implication:</a:t>
+            </a:r>
+          </a:p>
+          <a:p>
+            <a:pPr>
+              <a:spcAft>
+                <a:spcPts val="400"/>
+              </a:spcAft>
+              <a:defRPr sz="1600">
+                <a:solidFill>
+                  <a:srgbClr val="34495E"/>
+                </a:solidFill>
+              </a:defRPr>
+            </a:pPr>
+            <a:r>
+              <a:t>  At low-concentration sites, any of the three measurements</a:t>
+            </a:r>
+          </a:p>
+          <a:p>
+            <a:pPr>
+              <a:spcAft>
+                <a:spcPts val="400"/>
+              </a:spcAft>
+              <a:defRPr sz="1600">
+                <a:solidFill>
+                  <a:srgbClr val="34495E"/>
+                </a:solidFill>
+              </a:defRPr>
+            </a:pPr>
+            <a:r>
+              <a:t>  gives reasonable EC values.</a:t>
             </a:r>
           </a:p>
         </p:txBody>
@@ -5284,8 +5267,8 @@
         </p:nvSpPr>
         <p:spPr>
           <a:xfrm>
-            <a:off x="274320" y="182880"/>
-            <a:ext cx="11430000" cy="640080"/>
+            <a:off x="274320" y="137160"/>
+            <a:ext cx="11430000" cy="502920"/>
           </a:xfrm>
           <a:prstGeom prst="rect">
             <a:avLst/>
@@ -5299,14 +5282,14 @@
           <a:lstStyle/>
           <a:p>
             <a:pPr>
-              <a:defRPr sz="2400" b="1">
+              <a:defRPr sz="2200" b="1">
                 <a:solidFill>
                   <a:srgbClr val="2C3E50"/>
                 </a:solidFill>
               </a:defRPr>
             </a:pPr>
             <a:r>
-              <a:t>Result 5: Source Apportionment Does Not Separate the Problem</a:t>
+              <a:t>Result 4: Addis Problem Is Site-Specific, Not Concentration</a:t>
             </a:r>
           </a:p>
         </p:txBody>
@@ -5319,8 +5302,8 @@
         </p:nvSpPr>
         <p:spPr>
           <a:xfrm>
-            <a:off x="457200" y="914400"/>
-            <a:ext cx="10972800" cy="5486400"/>
+            <a:off x="457200" y="777240"/>
+            <a:ext cx="10972800" cy="5669280"/>
           </a:xfrm>
           <a:prstGeom prst="rect">
             <a:avLst/>
@@ -5335,199 +5318,205 @@
           <a:p>
             <a:pPr>
               <a:spcAft>
-                <a:spcPts val="800"/>
-              </a:spcAft>
-              <a:defRPr sz="1600">
-                <a:solidFill>
-                  <a:srgbClr val="2C3E50"/>
-                </a:solidFill>
-              </a:defRPr>
-            </a:pPr>
-            <a:r>
-              <a:t>PMF analysis (Naveed's data, Addis only — 5 factors):</a:t>
-            </a:r>
-          </a:p>
-          <a:p>
-            <a:pPr>
-              <a:spcAft>
-                <a:spcPts val="800"/>
-              </a:spcAft>
-              <a:defRPr sz="1600">
-                <a:solidFill>
-                  <a:srgbClr val="2C3E50"/>
-                </a:solidFill>
-              </a:defRPr>
-            </a:pPr>
-            <a:r>
-              <a:t>  Charcoal, Wood Burning, Fossil Fuel, Polluted Marine, Sea Salt</a:t>
-            </a:r>
-          </a:p>
-          <a:p>
-            <a:pPr>
-              <a:spcAft>
-                <a:spcPts val="800"/>
-              </a:spcAft>
-              <a:defRPr sz="1600">
-                <a:solidFill>
-                  <a:srgbClr val="2C3E50"/>
-                </a:solidFill>
-              </a:defRPr>
-            </a:pPr>
-          </a:p>
-          <a:p>
-            <a:pPr>
-              <a:spcAft>
-                <a:spcPts val="800"/>
-              </a:spcAft>
-              <a:defRPr sz="1600">
-                <a:solidFill>
-                  <a:srgbClr val="2C3E50"/>
-                </a:solidFill>
-              </a:defRPr>
-            </a:pPr>
-            <a:r>
-              <a:t>All combustion sources show similar slopes (~0.3-0.4) in HIPS vs FTIR EC.</a:t>
-            </a:r>
-          </a:p>
-          <a:p>
-            <a:pPr>
-              <a:spcAft>
-                <a:spcPts val="800"/>
-              </a:spcAft>
-              <a:defRPr sz="1600">
-                <a:solidFill>
-                  <a:srgbClr val="2C3E50"/>
-                </a:solidFill>
-              </a:defRPr>
-            </a:pPr>
-          </a:p>
-          <a:p>
-            <a:pPr>
-              <a:spcAft>
-                <a:spcPts val="800"/>
-              </a:spcAft>
-              <a:defRPr sz="1600">
-                <a:solidFill>
-                  <a:srgbClr val="2C3E50"/>
-                </a:solidFill>
-              </a:defRPr>
-            </a:pPr>
-            <a:r>
-              <a:t>Threshold filtering by dominant source % did not reveal</a:t>
-            </a:r>
-          </a:p>
-          <a:p>
-            <a:pPr>
-              <a:spcAft>
-                <a:spcPts val="800"/>
-              </a:spcAft>
-              <a:defRPr sz="1600">
-                <a:solidFill>
-                  <a:srgbClr val="2C3E50"/>
-                </a:solidFill>
-              </a:defRPr>
-            </a:pPr>
-            <a:r>
-              <a:t>source-specific mechanisms.</a:t>
-            </a:r>
-          </a:p>
-          <a:p>
-            <a:pPr>
-              <a:spcAft>
-                <a:spcPts val="800"/>
-              </a:spcAft>
-              <a:defRPr sz="1600">
-                <a:solidFill>
-                  <a:srgbClr val="2C3E50"/>
-                </a:solidFill>
-              </a:defRPr>
-            </a:pPr>
-          </a:p>
-          <a:p>
-            <a:pPr>
-              <a:spcAft>
-                <a:spcPts val="800"/>
-              </a:spcAft>
-              <a:defRPr sz="1600">
-                <a:solidFill>
-                  <a:srgbClr val="2C3E50"/>
-                </a:solidFill>
-              </a:defRPr>
-            </a:pPr>
-            <a:r>
-              <a:t>Combining charcoal+wood (biomass) vs fossil fuel+marine</a:t>
-            </a:r>
-          </a:p>
-          <a:p>
-            <a:pPr>
-              <a:spcAft>
-                <a:spcPts val="800"/>
-              </a:spcAft>
-              <a:defRPr sz="1600">
-                <a:solidFill>
-                  <a:srgbClr val="2C3E50"/>
-                </a:solidFill>
-              </a:defRPr>
-            </a:pPr>
-            <a:r>
-              <a:t>also did not separate — fossil fuel days fully overlap with</a:t>
-            </a:r>
-          </a:p>
-          <a:p>
-            <a:pPr>
-              <a:spcAft>
-                <a:spcPts val="800"/>
-              </a:spcAft>
-              <a:defRPr sz="1600">
-                <a:solidFill>
-                  <a:srgbClr val="2C3E50"/>
-                </a:solidFill>
-              </a:defRPr>
-            </a:pPr>
-            <a:r>
-              <a:t>biomass burning days.</a:t>
-            </a:r>
-          </a:p>
-          <a:p>
-            <a:pPr>
-              <a:spcAft>
-                <a:spcPts val="800"/>
-              </a:spcAft>
-              <a:defRPr sz="1600">
-                <a:solidFill>
-                  <a:srgbClr val="2C3E50"/>
-                </a:solidFill>
-              </a:defRPr>
-            </a:pPr>
-          </a:p>
-          <a:p>
-            <a:pPr>
-              <a:spcAft>
-                <a:spcPts val="800"/>
-              </a:spcAft>
-              <a:defRPr sz="1600">
-                <a:solidFill>
-                  <a:srgbClr val="2C3E50"/>
-                </a:solidFill>
-              </a:defRPr>
-            </a:pPr>
-            <a:r>
-              <a:t>One exception: Polluted marine behaves differently,</a:t>
-            </a:r>
-          </a:p>
-          <a:p>
-            <a:pPr>
-              <a:spcAft>
-                <a:spcPts val="800"/>
-              </a:spcAft>
-              <a:defRPr sz="1600">
-                <a:solidFill>
-                  <a:srgbClr val="2C3E50"/>
-                </a:solidFill>
-              </a:defRPr>
-            </a:pPr>
-            <a:r>
-              <a:t>but in OPPOSITE directions for HIPS vs aeth comparisons.</a:t>
+                <a:spcPts val="400"/>
+              </a:spcAft>
+              <a:defRPr sz="1600">
+                <a:solidFill>
+                  <a:srgbClr val="34495E"/>
+                </a:solidFill>
+              </a:defRPr>
+            </a:pPr>
+            <a:r>
+              <a:t>Delhi (63 paired samples):</a:t>
+            </a:r>
+          </a:p>
+          <a:p>
+            <a:pPr>
+              <a:spcAft>
+                <a:spcPts val="400"/>
+              </a:spcAft>
+              <a:defRPr sz="1600">
+                <a:solidFill>
+                  <a:srgbClr val="34495E"/>
+                </a:solidFill>
+              </a:defRPr>
+            </a:pPr>
+            <a:r>
+              <a:t>  Works well despite high concentrations (~11 ug/m3 median).</a:t>
+            </a:r>
+          </a:p>
+          <a:p>
+            <a:pPr>
+              <a:spcAft>
+                <a:spcPts val="400"/>
+              </a:spcAft>
+              <a:defRPr sz="1600">
+                <a:solidFill>
+                  <a:srgbClr val="34495E"/>
+                </a:solidFill>
+              </a:defRPr>
+            </a:pPr>
+            <a:r>
+              <a:t>  -&gt; Concentration alone does NOT explain the discrepancy.</a:t>
+            </a:r>
+          </a:p>
+          <a:p>
+            <a:pPr>
+              <a:spcAft>
+                <a:spcPts val="400"/>
+              </a:spcAft>
+              <a:defRPr sz="1600">
+                <a:solidFill>
+                  <a:srgbClr val="34495E"/>
+                </a:solidFill>
+              </a:defRPr>
+            </a:pPr>
+          </a:p>
+          <a:p>
+            <a:pPr>
+              <a:spcAft>
+                <a:spcPts val="400"/>
+              </a:spcAft>
+              <a:defRPr sz="1600">
+                <a:solidFill>
+                  <a:srgbClr val="34495E"/>
+                </a:solidFill>
+              </a:defRPr>
+            </a:pPr>
+            <a:r>
+              <a:t>Addis Ababa (190 paired samples):</a:t>
+            </a:r>
+          </a:p>
+          <a:p>
+            <a:pPr>
+              <a:spcAft>
+                <a:spcPts val="400"/>
+              </a:spcAft>
+              <a:defRPr sz="1600">
+                <a:solidFill>
+                  <a:srgbClr val="34495E"/>
+                </a:solidFill>
+              </a:defRPr>
+            </a:pPr>
+            <a:r>
+              <a:t>  - Persistent intercept: ~2 ug/m3 (no other site shows this)</a:t>
+            </a:r>
+          </a:p>
+          <a:p>
+            <a:pPr>
+              <a:spcAft>
+                <a:spcPts val="400"/>
+              </a:spcAft>
+              <a:defRPr sz="1600">
+                <a:solidFill>
+                  <a:srgbClr val="34495E"/>
+                </a:solidFill>
+              </a:defRPr>
+            </a:pPr>
+            <a:r>
+              <a:t>  - Slope: ~0.3 in HIPS vs FTIR EC (should be ~1.0)</a:t>
+            </a:r>
+          </a:p>
+          <a:p>
+            <a:pPr>
+              <a:spcAft>
+                <a:spcPts val="400"/>
+              </a:spcAft>
+              <a:defRPr sz="1600">
+                <a:solidFill>
+                  <a:srgbClr val="34495E"/>
+                </a:solidFill>
+              </a:defRPr>
+            </a:pPr>
+            <a:r>
+              <a:t>  - Problem is year-round — not limited to one season</a:t>
+            </a:r>
+          </a:p>
+          <a:p>
+            <a:pPr>
+              <a:spcAft>
+                <a:spcPts val="400"/>
+              </a:spcAft>
+              <a:defRPr sz="1600">
+                <a:solidFill>
+                  <a:srgbClr val="34495E"/>
+                </a:solidFill>
+              </a:defRPr>
+            </a:pPr>
+            <a:r>
+              <a:t>  - Problem is across all source types — charcoal, wood, fossil fuel</a:t>
+            </a:r>
+          </a:p>
+          <a:p>
+            <a:pPr>
+              <a:spcAft>
+                <a:spcPts val="400"/>
+              </a:spcAft>
+              <a:defRPr sz="1600">
+                <a:solidFill>
+                  <a:srgbClr val="34495E"/>
+                </a:solidFill>
+              </a:defRPr>
+            </a:pPr>
+            <a:r>
+              <a:t>    all show similar slopes</a:t>
+            </a:r>
+          </a:p>
+          <a:p>
+            <a:pPr>
+              <a:spcAft>
+                <a:spcPts val="400"/>
+              </a:spcAft>
+              <a:defRPr sz="1600">
+                <a:solidFill>
+                  <a:srgbClr val="34495E"/>
+                </a:solidFill>
+              </a:defRPr>
+            </a:pPr>
+          </a:p>
+          <a:p>
+            <a:pPr>
+              <a:spcAft>
+                <a:spcPts val="400"/>
+              </a:spcAft>
+              <a:defRPr sz="1600">
+                <a:solidFill>
+                  <a:srgbClr val="34495E"/>
+                </a:solidFill>
+              </a:defRPr>
+            </a:pPr>
+            <a:r>
+              <a:t>The anomaly has two DISTINCT co-occurring issues:</a:t>
+            </a:r>
+          </a:p>
+          <a:p>
+            <a:pPr>
+              <a:spcAft>
+                <a:spcPts val="400"/>
+              </a:spcAft>
+              <a:defRPr sz="1600">
+                <a:solidFill>
+                  <a:srgbClr val="34495E"/>
+                </a:solidFill>
+              </a:defRPr>
+            </a:pPr>
+            <a:r>
+              <a:t>  1. OFFSET: Large positive intercept</a:t>
+            </a:r>
+          </a:p>
+          <a:p>
+            <a:pPr>
+              <a:spcAft>
+                <a:spcPts val="400"/>
+              </a:spcAft>
+              <a:defRPr sz="1600">
+                <a:solidFill>
+                  <a:srgbClr val="34495E"/>
+                </a:solidFill>
+              </a:defRPr>
+            </a:pPr>
+            <a:r>
+              <a:t>  2. COMPRESSION: HIPS has much lower variability than EC or aeth</a:t>
             </a:r>
           </a:p>
         </p:txBody>
@@ -5558,8 +5547,8 @@
         </p:nvSpPr>
         <p:spPr>
           <a:xfrm>
-            <a:off x="274320" y="182880"/>
-            <a:ext cx="11430000" cy="640080"/>
+            <a:off x="274320" y="137160"/>
+            <a:ext cx="11430000" cy="502920"/>
           </a:xfrm>
           <a:prstGeom prst="rect">
             <a:avLst/>
@@ -5573,14 +5562,14 @@
           <a:lstStyle/>
           <a:p>
             <a:pPr>
-              <a:defRPr sz="2400" b="1">
+              <a:defRPr sz="2200" b="1">
                 <a:solidFill>
                   <a:srgbClr val="2C3E50"/>
                 </a:solidFill>
               </a:defRPr>
             </a:pPr>
             <a:r>
-              <a:t>Result 6: Approaches Tried — Scientific Narrowing</a:t>
+              <a:t>Result 5: Source Apportionment Does Not Separate the Problem</a:t>
             </a:r>
           </a:p>
         </p:txBody>
@@ -5593,8 +5582,8 @@
         </p:nvSpPr>
         <p:spPr>
           <a:xfrm>
-            <a:off x="457200" y="914400"/>
-            <a:ext cx="10972800" cy="5486400"/>
+            <a:off x="457200" y="777240"/>
+            <a:ext cx="10972800" cy="5669280"/>
           </a:xfrm>
           <a:prstGeom prst="rect">
             <a:avLst/>
@@ -5609,205 +5598,241 @@
           <a:p>
             <a:pPr>
               <a:spcAft>
-                <a:spcPts val="800"/>
-              </a:spcAft>
-              <a:defRPr sz="1600">
-                <a:solidFill>
-                  <a:srgbClr val="2C3E50"/>
-                </a:solidFill>
-              </a:defRPr>
-            </a:pPr>
-            <a:r>
-              <a:t>The following were tested and did NOT explain the Addis anomaly:</a:t>
-            </a:r>
-          </a:p>
-          <a:p>
-            <a:pPr>
-              <a:spcAft>
-                <a:spcPts val="800"/>
-              </a:spcAft>
-              <a:defRPr sz="1600">
-                <a:solidFill>
-                  <a:srgbClr val="2C3E50"/>
-                </a:solidFill>
-              </a:defRPr>
-            </a:pPr>
-          </a:p>
-          <a:p>
-            <a:pPr>
-              <a:spcAft>
-                <a:spcPts val="800"/>
-              </a:spcAft>
-              <a:defRPr sz="1600">
-                <a:solidFill>
-                  <a:srgbClr val="2C3E50"/>
-                </a:solidFill>
-              </a:defRPr>
-            </a:pPr>
-            <a:r>
-              <a:t>  1. Relative humidity thresholds -&gt; sample sizes too small</a:t>
-            </a:r>
-          </a:p>
-          <a:p>
-            <a:pPr>
-              <a:spcAft>
-                <a:spcPts val="800"/>
-              </a:spcAft>
-              <a:defRPr sz="1600">
-                <a:solidFill>
-                  <a:srgbClr val="2C3E50"/>
-                </a:solidFill>
-              </a:defRPr>
-            </a:pPr>
-            <a:r>
-              <a:t>  2. Temperature (T_min, T_max) -&gt; counterintuitive results</a:t>
-            </a:r>
-          </a:p>
-          <a:p>
-            <a:pPr>
-              <a:spcAft>
-                <a:spcPts val="800"/>
-              </a:spcAft>
-              <a:defRPr sz="1600">
-                <a:solidFill>
-                  <a:srgbClr val="2C3E50"/>
-                </a:solidFill>
-              </a:defRPr>
-            </a:pPr>
-            <a:r>
-              <a:t>  3. Optical saturation -&gt; no curvature in data</a:t>
-            </a:r>
-          </a:p>
-          <a:p>
-            <a:pPr>
-              <a:spcAft>
-                <a:spcPts val="800"/>
-              </a:spcAft>
-              <a:defRPr sz="1600">
-                <a:solidFill>
-                  <a:srgbClr val="2C3E50"/>
-                </a:solidFill>
-              </a:defRPr>
-            </a:pPr>
-            <a:r>
-              <a:t>  4. Influential point removal -&gt; dataset too tight</a:t>
-            </a:r>
-          </a:p>
-          <a:p>
-            <a:pPr>
-              <a:spcAft>
-                <a:spcPts val="800"/>
-              </a:spcAft>
-              <a:defRPr sz="1600">
-                <a:solidFill>
-                  <a:srgbClr val="2C3E50"/>
-                </a:solidFill>
-              </a:defRPr>
-            </a:pPr>
-            <a:r>
-              <a:t>  5. OC/EC ratio analysis -&gt; no insight</a:t>
-            </a:r>
-          </a:p>
-          <a:p>
-            <a:pPr>
-              <a:spcAft>
-                <a:spcPts val="800"/>
-              </a:spcAft>
-              <a:defRPr sz="1600">
-                <a:solidFill>
-                  <a:srgbClr val="2C3E50"/>
-                </a:solidFill>
-              </a:defRPr>
-            </a:pPr>
-            <a:r>
-              <a:t>  6. Iron/EC ratio thresholds -&gt; iron not causing discrepancies</a:t>
-            </a:r>
-          </a:p>
-          <a:p>
-            <a:pPr>
-              <a:spcAft>
-                <a:spcPts val="800"/>
-              </a:spcAft>
-              <a:defRPr sz="1600">
-                <a:solidFill>
-                  <a:srgbClr val="2C3E50"/>
-                </a:solidFill>
-              </a:defRPr>
-            </a:pPr>
-            <a:r>
-              <a:t>  7. Source apportionment (PMF, 5 factors) -&gt; sources don't separate</a:t>
-            </a:r>
-          </a:p>
-          <a:p>
-            <a:pPr>
-              <a:spcAft>
-                <a:spcPts val="800"/>
-              </a:spcAft>
-              <a:defRPr sz="1600">
-                <a:solidFill>
-                  <a:srgbClr val="2C3E50"/>
-                </a:solidFill>
-              </a:defRPr>
-            </a:pPr>
-            <a:r>
-              <a:t>  8. Combined source grouping -&gt; biomass vs fossil fuel overlap</a:t>
-            </a:r>
-          </a:p>
-          <a:p>
-            <a:pPr>
-              <a:spcAft>
-                <a:spcPts val="800"/>
-              </a:spcAft>
-              <a:defRPr sz="1600">
-                <a:solidFill>
-                  <a:srgbClr val="2C3E50"/>
-                </a:solidFill>
-              </a:defRPr>
-            </a:pPr>
-            <a:r>
-              <a:t>  9. All-season aggregation -&gt; masks patterns but doesn't explain</a:t>
-            </a:r>
-          </a:p>
-          <a:p>
-            <a:pPr>
-              <a:spcAft>
-                <a:spcPts val="800"/>
-              </a:spcAft>
-              <a:defRPr sz="1600">
-                <a:solidFill>
-                  <a:srgbClr val="2C3E50"/>
-                </a:solidFill>
-              </a:defRPr>
-            </a:pPr>
-          </a:p>
-          <a:p>
-            <a:pPr>
-              <a:spcAft>
-                <a:spcPts val="800"/>
-              </a:spcAft>
-              <a:defRPr sz="1600">
-                <a:solidFill>
-                  <a:srgbClr val="2C3E50"/>
-                </a:solidFill>
-              </a:defRPr>
-            </a:pPr>
-            <a:r>
-              <a:t>Each approach systematically eliminated a hypothesis.</a:t>
-            </a:r>
-          </a:p>
-          <a:p>
-            <a:pPr>
-              <a:spcAft>
-                <a:spcPts val="800"/>
-              </a:spcAft>
-              <a:defRPr sz="1600">
-                <a:solidFill>
-                  <a:srgbClr val="2C3E50"/>
-                </a:solidFill>
-              </a:defRPr>
-            </a:pPr>
-            <a:r>
-              <a:t>The root cause remains unidentified.</a:t>
+                <a:spcPts val="400"/>
+              </a:spcAft>
+              <a:defRPr sz="1600">
+                <a:solidFill>
+                  <a:srgbClr val="34495E"/>
+                </a:solidFill>
+              </a:defRPr>
+            </a:pPr>
+            <a:r>
+              <a:t>PMF analysis (Naveed's data, Addis only):</a:t>
+            </a:r>
+          </a:p>
+          <a:p>
+            <a:pPr>
+              <a:spcAft>
+                <a:spcPts val="400"/>
+              </a:spcAft>
+              <a:defRPr sz="1600">
+                <a:solidFill>
+                  <a:srgbClr val="34495E"/>
+                </a:solidFill>
+              </a:defRPr>
+            </a:pPr>
+            <a:r>
+              <a:t>  5 factors: Charcoal, Wood Burning, Fossil Fuel, Polluted Marine, Sea Salt</a:t>
+            </a:r>
+          </a:p>
+          <a:p>
+            <a:pPr>
+              <a:spcAft>
+                <a:spcPts val="400"/>
+              </a:spcAft>
+              <a:defRPr sz="1600">
+                <a:solidFill>
+                  <a:srgbClr val="34495E"/>
+                </a:solidFill>
+              </a:defRPr>
+            </a:pPr>
+          </a:p>
+          <a:p>
+            <a:pPr>
+              <a:spcAft>
+                <a:spcPts val="400"/>
+              </a:spcAft>
+              <a:defRPr sz="1600">
+                <a:solidFill>
+                  <a:srgbClr val="34495E"/>
+                </a:solidFill>
+              </a:defRPr>
+            </a:pPr>
+            <a:r>
+              <a:t>Dominant source breakdown:</a:t>
+            </a:r>
+          </a:p>
+          <a:p>
+            <a:pPr>
+              <a:spcAft>
+                <a:spcPts val="400"/>
+              </a:spcAft>
+              <a:defRPr sz="1600">
+                <a:solidFill>
+                  <a:srgbClr val="34495E"/>
+                </a:solidFill>
+              </a:defRPr>
+            </a:pPr>
+            <a:r>
+              <a:t>  Charcoal: 40 days | Wood: 25 | Fossil Fuel: 12 | Marine: 22 | Sea Salt: 3</a:t>
+            </a:r>
+          </a:p>
+          <a:p>
+            <a:pPr>
+              <a:spcAft>
+                <a:spcPts val="400"/>
+              </a:spcAft>
+              <a:defRPr sz="1600">
+                <a:solidFill>
+                  <a:srgbClr val="34495E"/>
+                </a:solidFill>
+              </a:defRPr>
+            </a:pPr>
+          </a:p>
+          <a:p>
+            <a:pPr>
+              <a:spcAft>
+                <a:spcPts val="400"/>
+              </a:spcAft>
+              <a:defRPr sz="1600">
+                <a:solidFill>
+                  <a:srgbClr val="34495E"/>
+                </a:solidFill>
+              </a:defRPr>
+            </a:pPr>
+            <a:r>
+              <a:t>All combustion sources show similar slopes (~0.3-0.4) in HIPS vs FTIR EC.</a:t>
+            </a:r>
+          </a:p>
+          <a:p>
+            <a:pPr>
+              <a:spcAft>
+                <a:spcPts val="400"/>
+              </a:spcAft>
+              <a:defRPr sz="1600">
+                <a:solidFill>
+                  <a:srgbClr val="34495E"/>
+                </a:solidFill>
+              </a:defRPr>
+            </a:pPr>
+          </a:p>
+          <a:p>
+            <a:pPr>
+              <a:spcAft>
+                <a:spcPts val="400"/>
+              </a:spcAft>
+              <a:defRPr sz="1600">
+                <a:solidFill>
+                  <a:srgbClr val="34495E"/>
+                </a:solidFill>
+              </a:defRPr>
+            </a:pPr>
+            <a:r>
+              <a:t>Threshold filtering by dominant source % (30-60%) did not reveal</a:t>
+            </a:r>
+          </a:p>
+          <a:p>
+            <a:pPr>
+              <a:spcAft>
+                <a:spcPts val="400"/>
+              </a:spcAft>
+              <a:defRPr sz="1600">
+                <a:solidFill>
+                  <a:srgbClr val="34495E"/>
+                </a:solidFill>
+              </a:defRPr>
+            </a:pPr>
+            <a:r>
+              <a:t>source-specific mechanisms. Slopes remained stable.</a:t>
+            </a:r>
+          </a:p>
+          <a:p>
+            <a:pPr>
+              <a:spcAft>
+                <a:spcPts val="400"/>
+              </a:spcAft>
+              <a:defRPr sz="1600">
+                <a:solidFill>
+                  <a:srgbClr val="34495E"/>
+                </a:solidFill>
+              </a:defRPr>
+            </a:pPr>
+          </a:p>
+          <a:p>
+            <a:pPr>
+              <a:spcAft>
+                <a:spcPts val="400"/>
+              </a:spcAft>
+              <a:defRPr sz="1600">
+                <a:solidFill>
+                  <a:srgbClr val="34495E"/>
+                </a:solidFill>
+              </a:defRPr>
+            </a:pPr>
+            <a:r>
+              <a:t>Combining charcoal+wood vs fossil fuel+marine:</a:t>
+            </a:r>
+          </a:p>
+          <a:p>
+            <a:pPr>
+              <a:spcAft>
+                <a:spcPts val="400"/>
+              </a:spcAft>
+              <a:defRPr sz="1600">
+                <a:solidFill>
+                  <a:srgbClr val="34495E"/>
+                </a:solidFill>
+              </a:defRPr>
+            </a:pPr>
+            <a:r>
+              <a:t>  Fossil fuel days fully overlap with biomass burning days.</a:t>
+            </a:r>
+          </a:p>
+          <a:p>
+            <a:pPr>
+              <a:spcAft>
+                <a:spcPts val="400"/>
+              </a:spcAft>
+              <a:defRPr sz="1600">
+                <a:solidFill>
+                  <a:srgbClr val="34495E"/>
+                </a:solidFill>
+              </a:defRPr>
+            </a:pPr>
+            <a:r>
+              <a:t>  No separation.</a:t>
+            </a:r>
+          </a:p>
+          <a:p>
+            <a:pPr>
+              <a:spcAft>
+                <a:spcPts val="400"/>
+              </a:spcAft>
+              <a:defRPr sz="1600">
+                <a:solidFill>
+                  <a:srgbClr val="34495E"/>
+                </a:solidFill>
+              </a:defRPr>
+            </a:pPr>
+          </a:p>
+          <a:p>
+            <a:pPr>
+              <a:spcAft>
+                <a:spcPts val="400"/>
+              </a:spcAft>
+              <a:defRPr sz="1600">
+                <a:solidFill>
+                  <a:srgbClr val="34495E"/>
+                </a:solidFill>
+              </a:defRPr>
+            </a:pPr>
+            <a:r>
+              <a:t>One exception: Polluted marine behaves differently from other sources</a:t>
+            </a:r>
+          </a:p>
+          <a:p>
+            <a:pPr>
+              <a:spcAft>
+                <a:spcPts val="400"/>
+              </a:spcAft>
+              <a:defRPr sz="1600">
+                <a:solidFill>
+                  <a:srgbClr val="34495E"/>
+                </a:solidFill>
+              </a:defRPr>
+            </a:pPr>
+            <a:r>
+              <a:t>but in OPPOSITE directions for HIPS vs aeth comparisons.</a:t>
             </a:r>
           </a:p>
         </p:txBody>

</xml_diff>